<commit_message>
Add health care use-case
</commit_message>
<xml_diff>
--- a/fig/food-supply-chain-tx-flow.pptx
+++ b/fig/food-supply-chain-tx-flow.pptx
@@ -261,7 +261,7 @@
           <a:p>
             <a:fld id="{CE74D935-525D-F244-B979-9EF8207529CF}" type="datetimeFigureOut">
               <a:rPr lang="en-US" smtClean="0"/>
-              <a:t>11/20/19</a:t>
+              <a:t>12/2/19</a:t>
             </a:fld>
             <a:endParaRPr lang="en-US"/>
           </a:p>
@@ -461,7 +461,7 @@
           <a:p>
             <a:fld id="{CE74D935-525D-F244-B979-9EF8207529CF}" type="datetimeFigureOut">
               <a:rPr lang="en-US" smtClean="0"/>
-              <a:t>11/20/19</a:t>
+              <a:t>12/2/19</a:t>
             </a:fld>
             <a:endParaRPr lang="en-US"/>
           </a:p>
@@ -671,7 +671,7 @@
           <a:p>
             <a:fld id="{CE74D935-525D-F244-B979-9EF8207529CF}" type="datetimeFigureOut">
               <a:rPr lang="en-US" smtClean="0"/>
-              <a:t>11/20/19</a:t>
+              <a:t>12/2/19</a:t>
             </a:fld>
             <a:endParaRPr lang="en-US"/>
           </a:p>
@@ -871,7 +871,7 @@
           <a:p>
             <a:fld id="{CE74D935-525D-F244-B979-9EF8207529CF}" type="datetimeFigureOut">
               <a:rPr lang="en-US" smtClean="0"/>
-              <a:t>11/20/19</a:t>
+              <a:t>12/2/19</a:t>
             </a:fld>
             <a:endParaRPr lang="en-US"/>
           </a:p>
@@ -1147,7 +1147,7 @@
           <a:p>
             <a:fld id="{CE74D935-525D-F244-B979-9EF8207529CF}" type="datetimeFigureOut">
               <a:rPr lang="en-US" smtClean="0"/>
-              <a:t>11/20/19</a:t>
+              <a:t>12/2/19</a:t>
             </a:fld>
             <a:endParaRPr lang="en-US"/>
           </a:p>
@@ -1415,7 +1415,7 @@
           <a:p>
             <a:fld id="{CE74D935-525D-F244-B979-9EF8207529CF}" type="datetimeFigureOut">
               <a:rPr lang="en-US" smtClean="0"/>
-              <a:t>11/20/19</a:t>
+              <a:t>12/2/19</a:t>
             </a:fld>
             <a:endParaRPr lang="en-US"/>
           </a:p>
@@ -1830,7 +1830,7 @@
           <a:p>
             <a:fld id="{CE74D935-525D-F244-B979-9EF8207529CF}" type="datetimeFigureOut">
               <a:rPr lang="en-US" smtClean="0"/>
-              <a:t>11/20/19</a:t>
+              <a:t>12/2/19</a:t>
             </a:fld>
             <a:endParaRPr lang="en-US"/>
           </a:p>
@@ -1972,7 +1972,7 @@
           <a:p>
             <a:fld id="{CE74D935-525D-F244-B979-9EF8207529CF}" type="datetimeFigureOut">
               <a:rPr lang="en-US" smtClean="0"/>
-              <a:t>11/20/19</a:t>
+              <a:t>12/2/19</a:t>
             </a:fld>
             <a:endParaRPr lang="en-US"/>
           </a:p>
@@ -2085,7 +2085,7 @@
           <a:p>
             <a:fld id="{CE74D935-525D-F244-B979-9EF8207529CF}" type="datetimeFigureOut">
               <a:rPr lang="en-US" smtClean="0"/>
-              <a:t>11/20/19</a:t>
+              <a:t>12/2/19</a:t>
             </a:fld>
             <a:endParaRPr lang="en-US"/>
           </a:p>
@@ -2398,7 +2398,7 @@
           <a:p>
             <a:fld id="{CE74D935-525D-F244-B979-9EF8207529CF}" type="datetimeFigureOut">
               <a:rPr lang="en-US" smtClean="0"/>
-              <a:t>11/20/19</a:t>
+              <a:t>12/2/19</a:t>
             </a:fld>
             <a:endParaRPr lang="en-US"/>
           </a:p>
@@ -2687,7 +2687,7 @@
           <a:p>
             <a:fld id="{CE74D935-525D-F244-B979-9EF8207529CF}" type="datetimeFigureOut">
               <a:rPr lang="en-US" smtClean="0"/>
-              <a:t>11/20/19</a:t>
+              <a:t>12/2/19</a:t>
             </a:fld>
             <a:endParaRPr lang="en-US"/>
           </a:p>
@@ -2930,7 +2930,7 @@
           <a:p>
             <a:fld id="{CE74D935-525D-F244-B979-9EF8207529CF}" type="datetimeFigureOut">
               <a:rPr lang="en-US" smtClean="0"/>
-              <a:t>11/20/19</a:t>
+              <a:t>12/2/19</a:t>
             </a:fld>
             <a:endParaRPr lang="en-US"/>
           </a:p>
@@ -3349,10 +3349,10 @@
       </p:grpSpPr>
       <p:sp>
         <p:nvSpPr>
-          <p:cNvPr id="4" name="Rectangle 3">
-            <a:extLst>
-              <a:ext uri="{FF2B5EF4-FFF2-40B4-BE49-F238E27FC236}">
-                <a16:creationId xmlns:a16="http://schemas.microsoft.com/office/drawing/2014/main" id="{11C6CC91-5868-B142-9F06-E3E29264F586}"/>
+          <p:cNvPr id="50" name="Rectangle 49">
+            <a:extLst>
+              <a:ext uri="{FF2B5EF4-FFF2-40B4-BE49-F238E27FC236}">
+                <a16:creationId xmlns:a16="http://schemas.microsoft.com/office/drawing/2014/main" id="{9D6D657F-D056-AA4D-8522-749725F40D54}"/>
               </a:ext>
             </a:extLst>
           </p:cNvPr>
@@ -3361,7 +3361,7 @@
         </p:nvSpPr>
         <p:spPr>
           <a:xfrm>
-            <a:off x="6873765" y="993230"/>
+            <a:off x="6416569" y="1947387"/>
             <a:ext cx="1140379" cy="294290"/>
           </a:xfrm>
           <a:prstGeom prst="rect">
@@ -3398,7 +3398,7 @@
           <a:p>
             <a:pPr algn="ctr"/>
             <a:r>
-              <a:rPr lang="en-US" dirty="0">
+              <a:rPr lang="en-US" b="1" dirty="0">
                 <a:latin typeface="Centaur" panose="02030504050205020304" pitchFamily="18" charset="77"/>
               </a:rPr>
               <a:t>Distributor</a:t>
@@ -3408,10 +3408,10 @@
       </p:sp>
       <p:sp>
         <p:nvSpPr>
-          <p:cNvPr id="5" name="Rectangle 4">
-            <a:extLst>
-              <a:ext uri="{FF2B5EF4-FFF2-40B4-BE49-F238E27FC236}">
-                <a16:creationId xmlns:a16="http://schemas.microsoft.com/office/drawing/2014/main" id="{F4FF4BEB-3E90-944E-B715-89FF3C3D5F6E}"/>
+          <p:cNvPr id="51" name="Rectangle 50">
+            <a:extLst>
+              <a:ext uri="{FF2B5EF4-FFF2-40B4-BE49-F238E27FC236}">
+                <a16:creationId xmlns:a16="http://schemas.microsoft.com/office/drawing/2014/main" id="{B037CBF6-8873-1042-9E29-9A58B007A68B}"/>
               </a:ext>
             </a:extLst>
           </p:cNvPr>
@@ -3420,8 +3420,8 @@
         </p:nvSpPr>
         <p:spPr>
           <a:xfrm>
-            <a:off x="8429293" y="995856"/>
-            <a:ext cx="1313802" cy="294290"/>
+            <a:off x="7962158" y="1950013"/>
+            <a:ext cx="1022811" cy="294290"/>
           </a:xfrm>
           <a:prstGeom prst="rect">
             <a:avLst/>
@@ -3449,33 +3449,20 @@
           <a:p>
             <a:pPr algn="ctr"/>
             <a:r>
-              <a:rPr lang="en-US" dirty="0">
-                <a:latin typeface="Centaur" panose="02030504050205020304" pitchFamily="18" charset="77"/>
-              </a:rPr>
-              <a:t>Retailer (R</a:t>
-            </a:r>
-            <a:r>
-              <a:rPr lang="en-US" b="1" baseline="-25000" dirty="0">
-                <a:latin typeface="Centaur" panose="02030504050205020304" pitchFamily="18" charset="77"/>
-                <a:cs typeface="Georgia Pro Semibold" panose="020F0502020204030204" pitchFamily="34" charset="0"/>
-              </a:rPr>
-              <a:t>4</a:t>
-            </a:r>
-            <a:r>
-              <a:rPr lang="en-US" dirty="0">
-                <a:latin typeface="Centaur" panose="02030504050205020304" pitchFamily="18" charset="77"/>
-              </a:rPr>
-              <a:t>)</a:t>
-            </a:r>
-          </a:p>
-        </p:txBody>
-      </p:sp>
-      <p:sp>
-        <p:nvSpPr>
-          <p:cNvPr id="6" name="Rectangle 5">
-            <a:extLst>
-              <a:ext uri="{FF2B5EF4-FFF2-40B4-BE49-F238E27FC236}">
-                <a16:creationId xmlns:a16="http://schemas.microsoft.com/office/drawing/2014/main" id="{E6160FAF-5E34-624C-BB9A-7A7280F8777E}"/>
+              <a:rPr lang="en-US" b="1" dirty="0">
+                <a:latin typeface="Centaur" panose="02030504050205020304" pitchFamily="18" charset="77"/>
+              </a:rPr>
+              <a:t>Retailer</a:t>
+            </a:r>
+          </a:p>
+        </p:txBody>
+      </p:sp>
+      <p:sp>
+        <p:nvSpPr>
+          <p:cNvPr id="52" name="Rectangle 51">
+            <a:extLst>
+              <a:ext uri="{FF2B5EF4-FFF2-40B4-BE49-F238E27FC236}">
+                <a16:creationId xmlns:a16="http://schemas.microsoft.com/office/drawing/2014/main" id="{C44D97A2-C838-8F42-9B5F-79A30F007A90}"/>
               </a:ext>
             </a:extLst>
           </p:cNvPr>
@@ -3484,7 +3471,7 @@
         </p:nvSpPr>
         <p:spPr>
           <a:xfrm>
-            <a:off x="5047589" y="993229"/>
+            <a:off x="4590393" y="1947386"/>
             <a:ext cx="1313802" cy="294291"/>
           </a:xfrm>
           <a:prstGeom prst="rect">
@@ -3518,20 +3505,20 @@
           <a:p>
             <a:pPr algn="ctr"/>
             <a:r>
-              <a:rPr lang="en-US" dirty="0">
-                <a:latin typeface="Centaur" panose="02030504050205020304" pitchFamily="18" charset="77"/>
-              </a:rPr>
-              <a:t>Manufacturer</a:t>
-            </a:r>
-          </a:p>
-        </p:txBody>
-      </p:sp>
-      <p:sp>
-        <p:nvSpPr>
-          <p:cNvPr id="7" name="Rectangle 6">
-            <a:extLst>
-              <a:ext uri="{FF2B5EF4-FFF2-40B4-BE49-F238E27FC236}">
-                <a16:creationId xmlns:a16="http://schemas.microsoft.com/office/drawing/2014/main" id="{8384EDBD-7097-F44F-9D0E-B700DB923EC1}"/>
+              <a:rPr lang="en-US" b="1" dirty="0">
+                <a:latin typeface="Centaur" panose="02030504050205020304" pitchFamily="18" charset="77"/>
+              </a:rPr>
+              <a:t>Manufacture</a:t>
+            </a:r>
+          </a:p>
+        </p:txBody>
+      </p:sp>
+      <p:sp>
+        <p:nvSpPr>
+          <p:cNvPr id="53" name="Rectangle 52">
+            <a:extLst>
+              <a:ext uri="{FF2B5EF4-FFF2-40B4-BE49-F238E27FC236}">
+                <a16:creationId xmlns:a16="http://schemas.microsoft.com/office/drawing/2014/main" id="{266E7A22-EA1D-794E-BDEA-15A52A6C039D}"/>
               </a:ext>
             </a:extLst>
           </p:cNvPr>
@@ -3540,7 +3527,7 @@
         </p:nvSpPr>
         <p:spPr>
           <a:xfrm>
-            <a:off x="3683869" y="993228"/>
+            <a:off x="3236612" y="1947385"/>
             <a:ext cx="893397" cy="296917"/>
           </a:xfrm>
           <a:prstGeom prst="rect">
@@ -3577,7 +3564,7 @@
           <a:p>
             <a:pPr algn="ctr"/>
             <a:r>
-              <a:rPr lang="en-US" dirty="0">
+              <a:rPr lang="en-US" b="1" dirty="0">
                 <a:latin typeface="Centaur" panose="02030504050205020304" pitchFamily="18" charset="77"/>
               </a:rPr>
               <a:t>Supplier</a:t>
@@ -3587,10 +3574,10 @@
       </p:sp>
       <p:sp>
         <p:nvSpPr>
-          <p:cNvPr id="8" name="Rectangle 7">
-            <a:extLst>
-              <a:ext uri="{FF2B5EF4-FFF2-40B4-BE49-F238E27FC236}">
-                <a16:creationId xmlns:a16="http://schemas.microsoft.com/office/drawing/2014/main" id="{311E54F1-5082-2743-B7D7-9258D8AD1E02}"/>
+          <p:cNvPr id="55" name="Rectangle 54">
+            <a:extLst>
+              <a:ext uri="{FF2B5EF4-FFF2-40B4-BE49-F238E27FC236}">
+                <a16:creationId xmlns:a16="http://schemas.microsoft.com/office/drawing/2014/main" id="{66F06CDE-C2DC-1A45-BC99-FE460F9CDBBD}"/>
               </a:ext>
             </a:extLst>
           </p:cNvPr>
@@ -3599,7 +3586,7 @@
         </p:nvSpPr>
         <p:spPr>
           <a:xfrm>
-            <a:off x="2249224" y="993230"/>
+            <a:off x="2040503" y="1947387"/>
             <a:ext cx="893397" cy="294290"/>
           </a:xfrm>
           <a:prstGeom prst="rect">
@@ -3636,7 +3623,7 @@
           <a:p>
             <a:pPr algn="ctr"/>
             <a:r>
-              <a:rPr lang="en-US" dirty="0">
+              <a:rPr lang="en-US" b="1" dirty="0">
                 <a:latin typeface="Centaur" panose="02030504050205020304" pitchFamily="18" charset="77"/>
               </a:rPr>
               <a:t>Farmer</a:t>
@@ -3646,28 +3633,28 @@
       </p:sp>
       <p:cxnSp>
         <p:nvCxnSpPr>
-          <p:cNvPr id="9" name="Elbow Connector 8">
-            <a:extLst>
-              <a:ext uri="{FF2B5EF4-FFF2-40B4-BE49-F238E27FC236}">
-                <a16:creationId xmlns:a16="http://schemas.microsoft.com/office/drawing/2014/main" id="{3FFFAC28-F1CD-744F-A231-482F31B698B8}"/>
+          <p:cNvPr id="59" name="Elbow Connector 58">
+            <a:extLst>
+              <a:ext uri="{FF2B5EF4-FFF2-40B4-BE49-F238E27FC236}">
+                <a16:creationId xmlns:a16="http://schemas.microsoft.com/office/drawing/2014/main" id="{3102D3E1-A7BE-8248-AA60-807A57D4FFFA}"/>
               </a:ext>
             </a:extLst>
           </p:cNvPr>
           <p:cNvCxnSpPr>
             <a:cxnSpLocks/>
-            <a:stCxn id="5" idx="1"/>
-            <a:endCxn id="4" idx="0"/>
+            <a:stCxn id="51" idx="1"/>
+            <a:endCxn id="50" idx="0"/>
           </p:cNvCxnSpPr>
           <p:nvPr/>
         </p:nvCxnSpPr>
         <p:spPr>
           <a:xfrm rot="10800000">
-            <a:off x="7443955" y="993231"/>
-            <a:ext cx="985338" cy="149771"/>
+            <a:off x="6986760" y="1947388"/>
+            <a:ext cx="975399" cy="149771"/>
           </a:xfrm>
           <a:prstGeom prst="bentConnector4">
             <a:avLst>
-              <a:gd name="adj1" fmla="val 21066"/>
+              <a:gd name="adj1" fmla="val 20771"/>
               <a:gd name="adj2" fmla="val 252633"/>
             </a:avLst>
           </a:prstGeom>
@@ -3698,23 +3685,23 @@
       </p:cxnSp>
       <p:cxnSp>
         <p:nvCxnSpPr>
-          <p:cNvPr id="10" name="Elbow Connector 9">
-            <a:extLst>
-              <a:ext uri="{FF2B5EF4-FFF2-40B4-BE49-F238E27FC236}">
-                <a16:creationId xmlns:a16="http://schemas.microsoft.com/office/drawing/2014/main" id="{25DE5C24-5C07-6249-8E1B-BFB75C1D7C38}"/>
+          <p:cNvPr id="60" name="Elbow Connector 59">
+            <a:extLst>
+              <a:ext uri="{FF2B5EF4-FFF2-40B4-BE49-F238E27FC236}">
+                <a16:creationId xmlns:a16="http://schemas.microsoft.com/office/drawing/2014/main" id="{15C89B65-7A4F-2444-9DF8-F9E93B6FF463}"/>
               </a:ext>
             </a:extLst>
           </p:cNvPr>
           <p:cNvCxnSpPr>
             <a:cxnSpLocks/>
-            <a:stCxn id="4" idx="1"/>
-            <a:endCxn id="6" idx="0"/>
+            <a:stCxn id="50" idx="1"/>
+            <a:endCxn id="52" idx="0"/>
           </p:cNvCxnSpPr>
           <p:nvPr/>
         </p:nvCxnSpPr>
         <p:spPr>
           <a:xfrm rot="10800000">
-            <a:off x="5704491" y="993229"/>
+            <a:off x="5247295" y="1947386"/>
             <a:ext cx="1169275" cy="147146"/>
           </a:xfrm>
           <a:prstGeom prst="bentConnector4">
@@ -3750,27 +3737,27 @@
       </p:cxnSp>
       <p:cxnSp>
         <p:nvCxnSpPr>
-          <p:cNvPr id="11" name="Elbow Connector 10">
-            <a:extLst>
-              <a:ext uri="{FF2B5EF4-FFF2-40B4-BE49-F238E27FC236}">
-                <a16:creationId xmlns:a16="http://schemas.microsoft.com/office/drawing/2014/main" id="{C222E01A-984A-2E42-B167-F556997AD72A}"/>
+          <p:cNvPr id="61" name="Elbow Connector 60">
+            <a:extLst>
+              <a:ext uri="{FF2B5EF4-FFF2-40B4-BE49-F238E27FC236}">
+                <a16:creationId xmlns:a16="http://schemas.microsoft.com/office/drawing/2014/main" id="{1D38C96B-B85C-ED45-BBF7-6A1E58BB73A3}"/>
               </a:ext>
             </a:extLst>
           </p:cNvPr>
           <p:cNvCxnSpPr>
-            <a:stCxn id="6" idx="1"/>
-            <a:endCxn id="7" idx="0"/>
+            <a:stCxn id="52" idx="1"/>
+            <a:endCxn id="53" idx="0"/>
           </p:cNvCxnSpPr>
           <p:nvPr/>
         </p:nvCxnSpPr>
         <p:spPr>
           <a:xfrm rot="10800000">
-            <a:off x="4130569" y="993229"/>
-            <a:ext cx="917021" cy="147147"/>
+            <a:off x="3683311" y="1947386"/>
+            <a:ext cx="907082" cy="147147"/>
           </a:xfrm>
           <a:prstGeom prst="bentConnector4">
             <a:avLst>
-              <a:gd name="adj1" fmla="val 25644"/>
+              <a:gd name="adj1" fmla="val 25377"/>
               <a:gd name="adj2" fmla="val 255355"/>
             </a:avLst>
           </a:prstGeom>
@@ -3801,27 +3788,27 @@
       </p:cxnSp>
       <p:cxnSp>
         <p:nvCxnSpPr>
-          <p:cNvPr id="12" name="Elbow Connector 11">
-            <a:extLst>
-              <a:ext uri="{FF2B5EF4-FFF2-40B4-BE49-F238E27FC236}">
-                <a16:creationId xmlns:a16="http://schemas.microsoft.com/office/drawing/2014/main" id="{5A5DF19F-42C8-EE48-B3FA-98A8BD519F7F}"/>
+          <p:cNvPr id="62" name="Elbow Connector 61">
+            <a:extLst>
+              <a:ext uri="{FF2B5EF4-FFF2-40B4-BE49-F238E27FC236}">
+                <a16:creationId xmlns:a16="http://schemas.microsoft.com/office/drawing/2014/main" id="{B2D9E530-D690-2C42-BB5F-0EE9393C129F}"/>
               </a:ext>
             </a:extLst>
           </p:cNvPr>
           <p:cNvCxnSpPr>
-            <a:stCxn id="7" idx="1"/>
-            <a:endCxn id="8" idx="0"/>
+            <a:stCxn id="53" idx="1"/>
+            <a:endCxn id="55" idx="0"/>
           </p:cNvCxnSpPr>
           <p:nvPr/>
         </p:nvCxnSpPr>
         <p:spPr>
           <a:xfrm rot="10800000">
-            <a:off x="2695923" y="993231"/>
-            <a:ext cx="987946" cy="148457"/>
+            <a:off x="2487202" y="1947388"/>
+            <a:ext cx="749410" cy="148457"/>
           </a:xfrm>
           <a:prstGeom prst="bentConnector4">
             <a:avLst>
-              <a:gd name="adj1" fmla="val 27393"/>
+              <a:gd name="adj1" fmla="val 20197"/>
               <a:gd name="adj2" fmla="val 253984"/>
             </a:avLst>
           </a:prstGeom>
@@ -3852,10 +3839,10 @@
       </p:cxnSp>
       <p:sp>
         <p:nvSpPr>
-          <p:cNvPr id="13" name="TextBox 12">
-            <a:extLst>
-              <a:ext uri="{FF2B5EF4-FFF2-40B4-BE49-F238E27FC236}">
-                <a16:creationId xmlns:a16="http://schemas.microsoft.com/office/drawing/2014/main" id="{5C21532C-A6E7-044F-8C6D-D537AF925B50}"/>
+          <p:cNvPr id="63" name="TextBox 62">
+            <a:extLst>
+              <a:ext uri="{FF2B5EF4-FFF2-40B4-BE49-F238E27FC236}">
+                <a16:creationId xmlns:a16="http://schemas.microsoft.com/office/drawing/2014/main" id="{9F3C9D15-3C6D-2C43-A2CB-B0024632A4D5}"/>
               </a:ext>
             </a:extLst>
           </p:cNvPr>
@@ -3864,8 +3851,8 @@
         </p:nvSpPr>
         <p:spPr>
           <a:xfrm>
-            <a:off x="7100470" y="428297"/>
-            <a:ext cx="1613968" cy="584775"/>
+            <a:off x="6166343" y="1324772"/>
+            <a:ext cx="1691873" cy="615553"/>
           </a:xfrm>
           <a:prstGeom prst="rect">
             <a:avLst/>
@@ -3886,8 +3873,9 @@
               <a:t>(</a:t>
             </a:r>
             <a:r>
-              <a:rPr lang="en-US" sz="1600" b="1" dirty="0">
-                <a:latin typeface="Centaur" panose="02030504050205020304" pitchFamily="18" charset="77"/>
+              <a:rPr lang="en-US" sz="1600" dirty="0">
+                <a:latin typeface="Times New Roman" panose="02020603050405020304" pitchFamily="18" charset="0"/>
+                <a:cs typeface="Times New Roman" panose="02020603050405020304" pitchFamily="18" charset="0"/>
               </a:rPr>
               <a:t>1</a:t>
             </a:r>
@@ -3895,13 +3883,19 @@
               <a:rPr lang="en-US" sz="1600" dirty="0">
                 <a:latin typeface="Centaur" panose="02030504050205020304" pitchFamily="18" charset="77"/>
               </a:rPr>
-              <a:t>) order chocolate</a:t>
+              <a:t>) </a:t>
+            </a:r>
+            <a:r>
+              <a:rPr lang="en-US" sz="1700" dirty="0">
+                <a:latin typeface="Centaur" panose="02030504050205020304" pitchFamily="18" charset="77"/>
+              </a:rPr>
+              <a:t>order chocolate</a:t>
             </a:r>
           </a:p>
           <a:p>
             <a:pPr algn="ctr"/>
             <a:r>
-              <a:rPr lang="en-US" sz="1600" dirty="0">
+              <a:rPr lang="en-US" sz="1700" dirty="0">
                 <a:latin typeface="Centaur" panose="02030504050205020304" pitchFamily="18" charset="77"/>
               </a:rPr>
               <a:t>bars </a:t>
@@ -3911,10 +3905,10 @@
       </p:sp>
       <p:sp>
         <p:nvSpPr>
-          <p:cNvPr id="14" name="TextBox 13">
-            <a:extLst>
-              <a:ext uri="{FF2B5EF4-FFF2-40B4-BE49-F238E27FC236}">
-                <a16:creationId xmlns:a16="http://schemas.microsoft.com/office/drawing/2014/main" id="{6F5D552A-D516-BE43-BF0A-CAF6258D918B}"/>
+          <p:cNvPr id="64" name="TextBox 63">
+            <a:extLst>
+              <a:ext uri="{FF2B5EF4-FFF2-40B4-BE49-F238E27FC236}">
+                <a16:creationId xmlns:a16="http://schemas.microsoft.com/office/drawing/2014/main" id="{268000D8-E0D1-F040-A7EB-0287A1D7204E}"/>
               </a:ext>
             </a:extLst>
           </p:cNvPr>
@@ -3923,8 +3917,8 @@
         </p:nvSpPr>
         <p:spPr>
           <a:xfrm>
-            <a:off x="5443113" y="428297"/>
-            <a:ext cx="1663662" cy="584775"/>
+            <a:off x="4583536" y="1321457"/>
+            <a:ext cx="1744773" cy="615553"/>
           </a:xfrm>
           <a:prstGeom prst="rect">
             <a:avLst/>
@@ -3945,8 +3939,9 @@
               <a:t>(</a:t>
             </a:r>
             <a:r>
-              <a:rPr lang="en-US" sz="1600" b="1" dirty="0">
-                <a:latin typeface="Centaur" panose="02030504050205020304" pitchFamily="18" charset="77"/>
+              <a:rPr lang="en-US" sz="1600" dirty="0">
+                <a:latin typeface="Times New Roman" panose="02020603050405020304" pitchFamily="18" charset="0"/>
+                <a:cs typeface="Times New Roman" panose="02020603050405020304" pitchFamily="18" charset="0"/>
               </a:rPr>
               <a:t>3</a:t>
             </a:r>
@@ -3954,13 +3949,19 @@
               <a:rPr lang="en-US" sz="1600" dirty="0">
                 <a:latin typeface="Centaur" panose="02030504050205020304" pitchFamily="18" charset="77"/>
               </a:rPr>
-              <a:t>) order chocolate </a:t>
+              <a:t>) </a:t>
+            </a:r>
+            <a:r>
+              <a:rPr lang="en-US" sz="1700" dirty="0">
+                <a:latin typeface="Centaur" panose="02030504050205020304" pitchFamily="18" charset="77"/>
+              </a:rPr>
+              <a:t>order chocolate </a:t>
             </a:r>
           </a:p>
           <a:p>
             <a:pPr algn="ctr"/>
             <a:r>
-              <a:rPr lang="en-US" sz="1600" dirty="0">
+              <a:rPr lang="en-US" sz="1700" dirty="0">
                 <a:latin typeface="Centaur" panose="02030504050205020304" pitchFamily="18" charset="77"/>
               </a:rPr>
               <a:t>bars </a:t>
@@ -3970,10 +3971,10 @@
       </p:sp>
       <p:sp>
         <p:nvSpPr>
-          <p:cNvPr id="15" name="TextBox 14">
-            <a:extLst>
-              <a:ext uri="{FF2B5EF4-FFF2-40B4-BE49-F238E27FC236}">
-                <a16:creationId xmlns:a16="http://schemas.microsoft.com/office/drawing/2014/main" id="{BE15E8A8-E802-3846-AB2D-FD4A0C788BA7}"/>
+          <p:cNvPr id="65" name="TextBox 64">
+            <a:extLst>
+              <a:ext uri="{FF2B5EF4-FFF2-40B4-BE49-F238E27FC236}">
+                <a16:creationId xmlns:a16="http://schemas.microsoft.com/office/drawing/2014/main" id="{D77AC9F9-51C2-7146-B81A-8C105919174D}"/>
               </a:ext>
             </a:extLst>
           </p:cNvPr>
@@ -3982,8 +3983,8 @@
         </p:nvSpPr>
         <p:spPr>
           <a:xfrm>
-            <a:off x="4004111" y="399394"/>
-            <a:ext cx="1229055" cy="584775"/>
+            <a:off x="3224349" y="1335964"/>
+            <a:ext cx="1281376" cy="615553"/>
           </a:xfrm>
           <a:prstGeom prst="rect">
             <a:avLst/>
@@ -4004,8 +4005,9 @@
               <a:t>(</a:t>
             </a:r>
             <a:r>
-              <a:rPr lang="en-US" sz="1600" b="1" dirty="0">
-                <a:latin typeface="Centaur" panose="02030504050205020304" pitchFamily="18" charset="77"/>
+              <a:rPr lang="en-US" sz="1600" dirty="0">
+                <a:latin typeface="Times New Roman" panose="02020603050405020304" pitchFamily="18" charset="0"/>
+                <a:cs typeface="Times New Roman" panose="02020603050405020304" pitchFamily="18" charset="0"/>
               </a:rPr>
               <a:t>5</a:t>
             </a:r>
@@ -4013,13 +4015,19 @@
               <a:rPr lang="en-US" sz="1600" dirty="0">
                 <a:latin typeface="Centaur" panose="02030504050205020304" pitchFamily="18" charset="77"/>
               </a:rPr>
-              <a:t>) order raw </a:t>
+              <a:t>) </a:t>
+            </a:r>
+            <a:r>
+              <a:rPr lang="en-US" sz="1700" dirty="0">
+                <a:latin typeface="Centaur" panose="02030504050205020304" pitchFamily="18" charset="77"/>
+              </a:rPr>
+              <a:t>order raw </a:t>
             </a:r>
           </a:p>
           <a:p>
             <a:pPr algn="ctr"/>
             <a:r>
-              <a:rPr lang="en-US" sz="1600" dirty="0">
+              <a:rPr lang="en-US" sz="1700" dirty="0">
                 <a:latin typeface="Centaur" panose="02030504050205020304" pitchFamily="18" charset="77"/>
               </a:rPr>
               <a:t>materials </a:t>
@@ -4029,10 +4037,10 @@
       </p:sp>
       <p:sp>
         <p:nvSpPr>
-          <p:cNvPr id="16" name="TextBox 15">
-            <a:extLst>
-              <a:ext uri="{FF2B5EF4-FFF2-40B4-BE49-F238E27FC236}">
-                <a16:creationId xmlns:a16="http://schemas.microsoft.com/office/drawing/2014/main" id="{ACA7FB40-C9B7-2E4B-B463-FEF600FEF9D6}"/>
+          <p:cNvPr id="66" name="TextBox 65">
+            <a:extLst>
+              <a:ext uri="{FF2B5EF4-FFF2-40B4-BE49-F238E27FC236}">
+                <a16:creationId xmlns:a16="http://schemas.microsoft.com/office/drawing/2014/main" id="{23E04F25-939C-8544-A5AC-EFA00322E86D}"/>
               </a:ext>
             </a:extLst>
           </p:cNvPr>
@@ -4041,8 +4049,8 @@
         </p:nvSpPr>
         <p:spPr>
           <a:xfrm>
-            <a:off x="2580005" y="425668"/>
-            <a:ext cx="1229055" cy="584775"/>
+            <a:off x="1949088" y="1321216"/>
+            <a:ext cx="1281376" cy="615553"/>
           </a:xfrm>
           <a:prstGeom prst="rect">
             <a:avLst/>
@@ -4063,8 +4071,9 @@
               <a:t>(</a:t>
             </a:r>
             <a:r>
-              <a:rPr lang="en-US" sz="1600" b="1" dirty="0">
-                <a:latin typeface="Centaur" panose="02030504050205020304" pitchFamily="18" charset="77"/>
+              <a:rPr lang="en-US" sz="1600" dirty="0">
+                <a:latin typeface="Times New Roman" panose="02020603050405020304" pitchFamily="18" charset="0"/>
+                <a:cs typeface="Times New Roman" panose="02020603050405020304" pitchFamily="18" charset="0"/>
               </a:rPr>
               <a:t>7</a:t>
             </a:r>
@@ -4072,13 +4081,19 @@
               <a:rPr lang="en-US" sz="1600" dirty="0">
                 <a:latin typeface="Centaur" panose="02030504050205020304" pitchFamily="18" charset="77"/>
               </a:rPr>
-              <a:t>) order raw </a:t>
+              <a:t>) </a:t>
+            </a:r>
+            <a:r>
+              <a:rPr lang="en-US" sz="1700" dirty="0">
+                <a:latin typeface="Centaur" panose="02030504050205020304" pitchFamily="18" charset="77"/>
+              </a:rPr>
+              <a:t>order raw </a:t>
             </a:r>
           </a:p>
           <a:p>
             <a:pPr algn="ctr"/>
             <a:r>
-              <a:rPr lang="en-US" sz="1600" dirty="0">
+              <a:rPr lang="en-US" sz="1700" dirty="0">
                 <a:latin typeface="Centaur" panose="02030504050205020304" pitchFamily="18" charset="77"/>
               </a:rPr>
               <a:t>materials </a:t>
@@ -4088,10 +4103,10 @@
       </p:sp>
       <p:sp>
         <p:nvSpPr>
-          <p:cNvPr id="17" name="Rounded Rectangle 16">
-            <a:extLst>
-              <a:ext uri="{FF2B5EF4-FFF2-40B4-BE49-F238E27FC236}">
-                <a16:creationId xmlns:a16="http://schemas.microsoft.com/office/drawing/2014/main" id="{D3A4AD16-F875-A04C-8A29-992413166D4F}"/>
+          <p:cNvPr id="67" name="Rounded Rectangle 66">
+            <a:extLst>
+              <a:ext uri="{FF2B5EF4-FFF2-40B4-BE49-F238E27FC236}">
+                <a16:creationId xmlns:a16="http://schemas.microsoft.com/office/drawing/2014/main" id="{B0761170-F30F-854B-A19B-D52EDC652F2D}"/>
               </a:ext>
             </a:extLst>
           </p:cNvPr>
@@ -4100,8 +4115,8 @@
         </p:nvSpPr>
         <p:spPr>
           <a:xfrm>
-            <a:off x="2937643" y="2563118"/>
-            <a:ext cx="1051036" cy="262758"/>
+            <a:off x="2589776" y="3517275"/>
+            <a:ext cx="960868" cy="262758"/>
           </a:xfrm>
           <a:prstGeom prst="roundRect">
             <a:avLst/>
@@ -4145,23 +4160,24 @@
       </p:sp>
       <p:cxnSp>
         <p:nvCxnSpPr>
-          <p:cNvPr id="18" name="Elbow Connector 17">
-            <a:extLst>
-              <a:ext uri="{FF2B5EF4-FFF2-40B4-BE49-F238E27FC236}">
-                <a16:creationId xmlns:a16="http://schemas.microsoft.com/office/drawing/2014/main" id="{2A2EDD34-F12B-7A48-9740-B0B460C55FB8}"/>
+          <p:cNvPr id="68" name="Elbow Connector 67">
+            <a:extLst>
+              <a:ext uri="{FF2B5EF4-FFF2-40B4-BE49-F238E27FC236}">
+                <a16:creationId xmlns:a16="http://schemas.microsoft.com/office/drawing/2014/main" id="{091339AD-0173-6E4D-A6D8-EA1132332F75}"/>
               </a:ext>
             </a:extLst>
           </p:cNvPr>
           <p:cNvCxnSpPr>
-            <a:stCxn id="7" idx="2"/>
-            <a:endCxn id="17" idx="3"/>
+            <a:cxnSpLocks/>
+            <a:stCxn id="53" idx="2"/>
+            <a:endCxn id="67" idx="3"/>
           </p:cNvCxnSpPr>
           <p:nvPr/>
         </p:nvCxnSpPr>
         <p:spPr>
           <a:xfrm rot="5400000">
-            <a:off x="3357448" y="1921377"/>
-            <a:ext cx="1404352" cy="141889"/>
+            <a:off x="2914802" y="2880145"/>
+            <a:ext cx="1404352" cy="132667"/>
           </a:xfrm>
           <a:prstGeom prst="bentConnector2">
             <a:avLst/>
@@ -4193,23 +4209,24 @@
       </p:cxnSp>
       <p:cxnSp>
         <p:nvCxnSpPr>
-          <p:cNvPr id="19" name="Elbow Connector 18">
-            <a:extLst>
-              <a:ext uri="{FF2B5EF4-FFF2-40B4-BE49-F238E27FC236}">
-                <a16:creationId xmlns:a16="http://schemas.microsoft.com/office/drawing/2014/main" id="{4E45BA27-3A54-524D-BA97-BC24317F8B09}"/>
+          <p:cNvPr id="69" name="Elbow Connector 68">
+            <a:extLst>
+              <a:ext uri="{FF2B5EF4-FFF2-40B4-BE49-F238E27FC236}">
+                <a16:creationId xmlns:a16="http://schemas.microsoft.com/office/drawing/2014/main" id="{2D3514D5-F69C-6A4B-B1EF-CCE2E8640D4E}"/>
               </a:ext>
             </a:extLst>
           </p:cNvPr>
           <p:cNvCxnSpPr>
-            <a:stCxn id="17" idx="1"/>
-            <a:endCxn id="8" idx="2"/>
+            <a:cxnSpLocks/>
+            <a:stCxn id="67" idx="1"/>
+            <a:endCxn id="55" idx="2"/>
           </p:cNvCxnSpPr>
           <p:nvPr/>
         </p:nvCxnSpPr>
         <p:spPr>
           <a:xfrm rot="10800000">
-            <a:off x="2695923" y="1287521"/>
-            <a:ext cx="241720" cy="1406977"/>
+            <a:off x="2487202" y="2241678"/>
+            <a:ext cx="102574" cy="1406977"/>
           </a:xfrm>
           <a:prstGeom prst="bentConnector2">
             <a:avLst/>
@@ -4241,10 +4258,10 @@
       </p:cxnSp>
       <p:sp>
         <p:nvSpPr>
-          <p:cNvPr id="20" name="TextBox 19">
-            <a:extLst>
-              <a:ext uri="{FF2B5EF4-FFF2-40B4-BE49-F238E27FC236}">
-                <a16:creationId xmlns:a16="http://schemas.microsoft.com/office/drawing/2014/main" id="{D4D58620-8C71-6645-8159-3A4FAD2D31FF}"/>
+          <p:cNvPr id="70" name="TextBox 69">
+            <a:extLst>
+              <a:ext uri="{FF2B5EF4-FFF2-40B4-BE49-F238E27FC236}">
+                <a16:creationId xmlns:a16="http://schemas.microsoft.com/office/drawing/2014/main" id="{F78047C6-191E-9140-80A0-DF712D21D827}"/>
               </a:ext>
             </a:extLst>
           </p:cNvPr>
@@ -4253,8 +4270,8 @@
         </p:nvSpPr>
         <p:spPr>
           <a:xfrm>
-            <a:off x="2918845" y="2271729"/>
-            <a:ext cx="2403441" cy="338554"/>
+            <a:off x="2710124" y="3186130"/>
+            <a:ext cx="2403441" cy="353943"/>
           </a:xfrm>
           <a:prstGeom prst="rect">
             <a:avLst/>
@@ -4275,8 +4292,9 @@
               <a:t>(</a:t>
             </a:r>
             <a:r>
-              <a:rPr lang="en-US" sz="1600" b="1" dirty="0">
-                <a:latin typeface="Centaur" panose="02030504050205020304" pitchFamily="18" charset="77"/>
+              <a:rPr lang="en-US" sz="1600" dirty="0">
+                <a:latin typeface="Times New Roman" panose="02020603050405020304" pitchFamily="18" charset="0"/>
+                <a:cs typeface="Times New Roman" panose="02020603050405020304" pitchFamily="18" charset="0"/>
               </a:rPr>
               <a:t>9</a:t>
             </a:r>
@@ -4284,17 +4302,23 @@
               <a:rPr lang="en-US" sz="1600" dirty="0">
                 <a:latin typeface="Centaur" panose="02030504050205020304" pitchFamily="18" charset="77"/>
               </a:rPr>
-              <a:t>) arrange shipping</a:t>
-            </a:r>
-          </a:p>
-        </p:txBody>
-      </p:sp>
-      <p:sp>
-        <p:nvSpPr>
-          <p:cNvPr id="21" name="TextBox 20">
-            <a:extLst>
-              <a:ext uri="{FF2B5EF4-FFF2-40B4-BE49-F238E27FC236}">
-                <a16:creationId xmlns:a16="http://schemas.microsoft.com/office/drawing/2014/main" id="{DEEC0D70-D726-3848-8733-ACF896FE2AF4}"/>
+              <a:t>) </a:t>
+            </a:r>
+            <a:r>
+              <a:rPr lang="en-US" sz="1700" dirty="0">
+                <a:latin typeface="Centaur" panose="02030504050205020304" pitchFamily="18" charset="77"/>
+              </a:rPr>
+              <a:t>arrange shipping</a:t>
+            </a:r>
+          </a:p>
+        </p:txBody>
+      </p:sp>
+      <p:sp>
+        <p:nvSpPr>
+          <p:cNvPr id="71" name="TextBox 70">
+            <a:extLst>
+              <a:ext uri="{FF2B5EF4-FFF2-40B4-BE49-F238E27FC236}">
+                <a16:creationId xmlns:a16="http://schemas.microsoft.com/office/drawing/2014/main" id="{26108791-9F68-5B48-8218-A40A67FDACFD}"/>
               </a:ext>
             </a:extLst>
           </p:cNvPr>
@@ -4303,8 +4327,8 @@
         </p:nvSpPr>
         <p:spPr>
           <a:xfrm>
-            <a:off x="2120199" y="2109910"/>
-            <a:ext cx="1180644" cy="584775"/>
+            <a:off x="1911447" y="2924921"/>
+            <a:ext cx="1220463" cy="615553"/>
           </a:xfrm>
           <a:prstGeom prst="rect">
             <a:avLst/>
@@ -4325,8 +4349,9 @@
               <a:t>(</a:t>
             </a:r>
             <a:r>
-              <a:rPr lang="en-US" sz="1600" b="1" dirty="0">
-                <a:latin typeface="Centaur" panose="02030504050205020304" pitchFamily="18" charset="77"/>
+              <a:rPr lang="en-US" sz="1600" dirty="0">
+                <a:latin typeface="Times New Roman" panose="02020603050405020304" pitchFamily="18" charset="0"/>
+                <a:cs typeface="Times New Roman" panose="02020603050405020304" pitchFamily="18" charset="0"/>
               </a:rPr>
               <a:t>10</a:t>
             </a:r>
@@ -4334,15 +4359,21 @@
               <a:rPr lang="en-US" sz="1600" dirty="0">
                 <a:latin typeface="Centaur" panose="02030504050205020304" pitchFamily="18" charset="77"/>
               </a:rPr>
-              <a:t>) pick up </a:t>
+              <a:t>) </a:t>
+            </a:r>
+            <a:r>
+              <a:rPr lang="en-US" sz="1700" dirty="0">
+                <a:latin typeface="Centaur" panose="02030504050205020304" pitchFamily="18" charset="77"/>
+              </a:rPr>
+              <a:t>pick up </a:t>
             </a:r>
             <a:br>
-              <a:rPr lang="en-US" sz="1600" dirty="0">
+              <a:rPr lang="en-US" sz="1700" dirty="0">
                 <a:latin typeface="Centaur" panose="02030504050205020304" pitchFamily="18" charset="77"/>
               </a:rPr>
             </a:br>
             <a:r>
-              <a:rPr lang="en-US" sz="1600" dirty="0">
+              <a:rPr lang="en-US" sz="1700" dirty="0">
                 <a:latin typeface="Centaur" panose="02030504050205020304" pitchFamily="18" charset="77"/>
               </a:rPr>
               <a:t>order</a:t>
@@ -4352,10 +4383,10 @@
       </p:sp>
       <p:cxnSp>
         <p:nvCxnSpPr>
-          <p:cNvPr id="22" name="Straight Arrow Connector 21">
-            <a:extLst>
-              <a:ext uri="{FF2B5EF4-FFF2-40B4-BE49-F238E27FC236}">
-                <a16:creationId xmlns:a16="http://schemas.microsoft.com/office/drawing/2014/main" id="{81C798F8-E4D2-CB46-9C21-5933DD8CBAC1}"/>
+          <p:cNvPr id="72" name="Straight Arrow Connector 71">
+            <a:extLst>
+              <a:ext uri="{FF2B5EF4-FFF2-40B4-BE49-F238E27FC236}">
+                <a16:creationId xmlns:a16="http://schemas.microsoft.com/office/drawing/2014/main" id="{01968D52-1BC5-424E-B932-B4692464EA15}"/>
               </a:ext>
             </a:extLst>
           </p:cNvPr>
@@ -4364,7 +4395,7 @@
         </p:nvCxnSpPr>
         <p:spPr>
           <a:xfrm>
-            <a:off x="3142621" y="1287520"/>
+            <a:off x="2933900" y="2241677"/>
             <a:ext cx="541248" cy="0"/>
           </a:xfrm>
           <a:prstGeom prst="straightConnector1">
@@ -4397,10 +4428,10 @@
       </p:cxnSp>
       <p:cxnSp>
         <p:nvCxnSpPr>
-          <p:cNvPr id="23" name="Straight Arrow Connector 22">
-            <a:extLst>
-              <a:ext uri="{FF2B5EF4-FFF2-40B4-BE49-F238E27FC236}">
-                <a16:creationId xmlns:a16="http://schemas.microsoft.com/office/drawing/2014/main" id="{3E1C4C45-BCE7-0B4D-801B-D2D2BF79B199}"/>
+          <p:cNvPr id="73" name="Straight Arrow Connector 72">
+            <a:extLst>
+              <a:ext uri="{FF2B5EF4-FFF2-40B4-BE49-F238E27FC236}">
+                <a16:creationId xmlns:a16="http://schemas.microsoft.com/office/drawing/2014/main" id="{5C30C58E-6F17-4440-8A68-A98B848F035E}"/>
               </a:ext>
             </a:extLst>
           </p:cNvPr>
@@ -4409,7 +4440,7 @@
         </p:nvCxnSpPr>
         <p:spPr>
           <a:xfrm>
-            <a:off x="4589079" y="1287520"/>
+            <a:off x="4158752" y="2241676"/>
             <a:ext cx="458510" cy="0"/>
           </a:xfrm>
           <a:prstGeom prst="straightConnector1">
@@ -4442,10 +4473,10 @@
       </p:cxnSp>
       <p:cxnSp>
         <p:nvCxnSpPr>
-          <p:cNvPr id="24" name="Straight Arrow Connector 23">
-            <a:extLst>
-              <a:ext uri="{FF2B5EF4-FFF2-40B4-BE49-F238E27FC236}">
-                <a16:creationId xmlns:a16="http://schemas.microsoft.com/office/drawing/2014/main" id="{8CCA5BD0-8245-9B47-B162-D01776C13D46}"/>
+          <p:cNvPr id="74" name="Straight Arrow Connector 73">
+            <a:extLst>
+              <a:ext uri="{FF2B5EF4-FFF2-40B4-BE49-F238E27FC236}">
+                <a16:creationId xmlns:a16="http://schemas.microsoft.com/office/drawing/2014/main" id="{ADAD45E2-F415-7B4C-BA5C-21AFDD39902C}"/>
               </a:ext>
             </a:extLst>
           </p:cNvPr>
@@ -4454,7 +4485,7 @@
         </p:nvCxnSpPr>
         <p:spPr>
           <a:xfrm>
-            <a:off x="6361391" y="1287520"/>
+            <a:off x="5907083" y="2227170"/>
             <a:ext cx="512374" cy="0"/>
           </a:xfrm>
           <a:prstGeom prst="straightConnector1">
@@ -4487,10 +4518,10 @@
       </p:cxnSp>
       <p:cxnSp>
         <p:nvCxnSpPr>
-          <p:cNvPr id="25" name="Straight Arrow Connector 24">
-            <a:extLst>
-              <a:ext uri="{FF2B5EF4-FFF2-40B4-BE49-F238E27FC236}">
-                <a16:creationId xmlns:a16="http://schemas.microsoft.com/office/drawing/2014/main" id="{2CECC795-F0DD-E049-B367-A837E291D46E}"/>
+          <p:cNvPr id="75" name="Straight Arrow Connector 74">
+            <a:extLst>
+              <a:ext uri="{FF2B5EF4-FFF2-40B4-BE49-F238E27FC236}">
+                <a16:creationId xmlns:a16="http://schemas.microsoft.com/office/drawing/2014/main" id="{2E0E6AF2-ED53-BC49-A1FC-D1DEF2361BC4}"/>
               </a:ext>
             </a:extLst>
           </p:cNvPr>
@@ -4499,7 +4530,7 @@
         </p:nvCxnSpPr>
         <p:spPr>
           <a:xfrm>
-            <a:off x="8014144" y="1287520"/>
+            <a:off x="7556948" y="2241676"/>
             <a:ext cx="415149" cy="0"/>
           </a:xfrm>
           <a:prstGeom prst="straightConnector1">
@@ -4532,10 +4563,10 @@
       </p:cxnSp>
       <p:sp>
         <p:nvSpPr>
-          <p:cNvPr id="26" name="TextBox 25">
-            <a:extLst>
-              <a:ext uri="{FF2B5EF4-FFF2-40B4-BE49-F238E27FC236}">
-                <a16:creationId xmlns:a16="http://schemas.microsoft.com/office/drawing/2014/main" id="{A4A50E44-8B57-D041-BC4E-50A2AD322D76}"/>
+          <p:cNvPr id="76" name="TextBox 75">
+            <a:extLst>
+              <a:ext uri="{FF2B5EF4-FFF2-40B4-BE49-F238E27FC236}">
+                <a16:creationId xmlns:a16="http://schemas.microsoft.com/office/drawing/2014/main" id="{4FB9914D-C905-784A-AE8C-37B4B12CD8D2}"/>
               </a:ext>
             </a:extLst>
           </p:cNvPr>
@@ -4544,8 +4575,8 @@
         </p:nvSpPr>
         <p:spPr>
           <a:xfrm>
-            <a:off x="7689037" y="1221889"/>
-            <a:ext cx="987258" cy="338554"/>
+            <a:off x="7231274" y="2173847"/>
+            <a:ext cx="1020216" cy="353943"/>
           </a:xfrm>
           <a:prstGeom prst="rect">
             <a:avLst/>
@@ -4574,17 +4605,23 @@
               <a:rPr lang="en-US" sz="1600" dirty="0">
                 <a:latin typeface="Centaur" panose="02030504050205020304" pitchFamily="18" charset="77"/>
               </a:rPr>
-              <a:t>) invoice</a:t>
-            </a:r>
-          </a:p>
-        </p:txBody>
-      </p:sp>
-      <p:sp>
-        <p:nvSpPr>
-          <p:cNvPr id="27" name="TextBox 26">
-            <a:extLst>
-              <a:ext uri="{FF2B5EF4-FFF2-40B4-BE49-F238E27FC236}">
-                <a16:creationId xmlns:a16="http://schemas.microsoft.com/office/drawing/2014/main" id="{C2B148EC-7E38-4547-AF26-BE8B41E8CA84}"/>
+              <a:t>) </a:t>
+            </a:r>
+            <a:r>
+              <a:rPr lang="en-US" sz="1700" dirty="0">
+                <a:latin typeface="Centaur" panose="02030504050205020304" pitchFamily="18" charset="77"/>
+              </a:rPr>
+              <a:t>invoice</a:t>
+            </a:r>
+          </a:p>
+        </p:txBody>
+      </p:sp>
+      <p:sp>
+        <p:nvSpPr>
+          <p:cNvPr id="77" name="TextBox 76">
+            <a:extLst>
+              <a:ext uri="{FF2B5EF4-FFF2-40B4-BE49-F238E27FC236}">
+                <a16:creationId xmlns:a16="http://schemas.microsoft.com/office/drawing/2014/main" id="{3307FEAE-7198-AD4A-84B8-E261EF9BC582}"/>
               </a:ext>
             </a:extLst>
           </p:cNvPr>
@@ -4593,8 +4630,8 @@
         </p:nvSpPr>
         <p:spPr>
           <a:xfrm>
-            <a:off x="6163555" y="1238110"/>
-            <a:ext cx="987258" cy="338554"/>
+            <a:off x="5778896" y="2143748"/>
+            <a:ext cx="1021818" cy="353943"/>
           </a:xfrm>
           <a:prstGeom prst="rect">
             <a:avLst/>
@@ -4614,8 +4651,9 @@
               <a:t>(</a:t>
             </a:r>
             <a:r>
-              <a:rPr lang="en-US" sz="1600" b="1" dirty="0">
-                <a:latin typeface="Centaur" panose="02030504050205020304" pitchFamily="18" charset="77"/>
+              <a:rPr lang="en-US" sz="1600" dirty="0">
+                <a:latin typeface="Times New Roman" panose="02020603050405020304" pitchFamily="18" charset="0"/>
+                <a:cs typeface="Times New Roman" panose="02020603050405020304" pitchFamily="18" charset="0"/>
               </a:rPr>
               <a:t>4</a:t>
             </a:r>
@@ -4623,17 +4661,23 @@
               <a:rPr lang="en-US" sz="1600" dirty="0">
                 <a:latin typeface="Centaur" panose="02030504050205020304" pitchFamily="18" charset="77"/>
               </a:rPr>
-              <a:t>) invoice</a:t>
-            </a:r>
-          </a:p>
-        </p:txBody>
-      </p:sp>
-      <p:sp>
-        <p:nvSpPr>
-          <p:cNvPr id="28" name="TextBox 27">
-            <a:extLst>
-              <a:ext uri="{FF2B5EF4-FFF2-40B4-BE49-F238E27FC236}">
-                <a16:creationId xmlns:a16="http://schemas.microsoft.com/office/drawing/2014/main" id="{CBC87C60-6AC6-6149-B96A-300D76BF11F0}"/>
+              <a:t>) </a:t>
+            </a:r>
+            <a:r>
+              <a:rPr lang="en-US" sz="1700" dirty="0">
+                <a:latin typeface="Centaur" panose="02030504050205020304" pitchFamily="18" charset="77"/>
+              </a:rPr>
+              <a:t>invoice</a:t>
+            </a:r>
+          </a:p>
+        </p:txBody>
+      </p:sp>
+      <p:sp>
+        <p:nvSpPr>
+          <p:cNvPr id="78" name="TextBox 77">
+            <a:extLst>
+              <a:ext uri="{FF2B5EF4-FFF2-40B4-BE49-F238E27FC236}">
+                <a16:creationId xmlns:a16="http://schemas.microsoft.com/office/drawing/2014/main" id="{D387AFE5-55C2-564F-AA7A-9FBB11EDB83C}"/>
               </a:ext>
             </a:extLst>
           </p:cNvPr>
@@ -4642,8 +4686,8 @@
         </p:nvSpPr>
         <p:spPr>
           <a:xfrm>
-            <a:off x="4349679" y="1213229"/>
-            <a:ext cx="987258" cy="338554"/>
+            <a:off x="3860886" y="2177220"/>
+            <a:ext cx="1021818" cy="353943"/>
           </a:xfrm>
           <a:prstGeom prst="rect">
             <a:avLst/>
@@ -4663,8 +4707,9 @@
               <a:t>(</a:t>
             </a:r>
             <a:r>
-              <a:rPr lang="en-US" sz="1600" b="1" dirty="0">
-                <a:latin typeface="Centaur" panose="02030504050205020304" pitchFamily="18" charset="77"/>
+              <a:rPr lang="en-US" sz="1600" dirty="0">
+                <a:latin typeface="Times New Roman" panose="02020603050405020304" pitchFamily="18" charset="0"/>
+                <a:cs typeface="Times New Roman" panose="02020603050405020304" pitchFamily="18" charset="0"/>
               </a:rPr>
               <a:t>6</a:t>
             </a:r>
@@ -4672,17 +4717,23 @@
               <a:rPr lang="en-US" sz="1600" dirty="0">
                 <a:latin typeface="Centaur" panose="02030504050205020304" pitchFamily="18" charset="77"/>
               </a:rPr>
-              <a:t>) invoice</a:t>
-            </a:r>
-          </a:p>
-        </p:txBody>
-      </p:sp>
-      <p:sp>
-        <p:nvSpPr>
-          <p:cNvPr id="29" name="TextBox 28">
-            <a:extLst>
-              <a:ext uri="{FF2B5EF4-FFF2-40B4-BE49-F238E27FC236}">
-                <a16:creationId xmlns:a16="http://schemas.microsoft.com/office/drawing/2014/main" id="{ACEC3611-1D50-1648-8441-274B9C60E7A9}"/>
+              <a:t>) </a:t>
+            </a:r>
+            <a:r>
+              <a:rPr lang="en-US" sz="1700" dirty="0">
+                <a:latin typeface="Centaur" panose="02030504050205020304" pitchFamily="18" charset="77"/>
+              </a:rPr>
+              <a:t>invoice</a:t>
+            </a:r>
+          </a:p>
+        </p:txBody>
+      </p:sp>
+      <p:sp>
+        <p:nvSpPr>
+          <p:cNvPr id="79" name="TextBox 78">
+            <a:extLst>
+              <a:ext uri="{FF2B5EF4-FFF2-40B4-BE49-F238E27FC236}">
+                <a16:creationId xmlns:a16="http://schemas.microsoft.com/office/drawing/2014/main" id="{FEFE77D7-16ED-984E-A2AB-11F31A2A0BC0}"/>
               </a:ext>
             </a:extLst>
           </p:cNvPr>
@@ -4691,8 +4742,8 @@
         </p:nvSpPr>
         <p:spPr>
           <a:xfrm>
-            <a:off x="2872373" y="1201421"/>
-            <a:ext cx="987258" cy="338554"/>
+            <a:off x="2663652" y="2155578"/>
+            <a:ext cx="1021818" cy="353943"/>
           </a:xfrm>
           <a:prstGeom prst="rect">
             <a:avLst/>
@@ -4712,8 +4763,9 @@
               <a:t>(</a:t>
             </a:r>
             <a:r>
-              <a:rPr lang="en-US" sz="1600" b="1" dirty="0">
-                <a:latin typeface="Centaur" panose="02030504050205020304" pitchFamily="18" charset="77"/>
+              <a:rPr lang="en-US" sz="1600" dirty="0">
+                <a:latin typeface="Times New Roman" panose="02020603050405020304" pitchFamily="18" charset="0"/>
+                <a:cs typeface="Times New Roman" panose="02020603050405020304" pitchFamily="18" charset="0"/>
               </a:rPr>
               <a:t>8</a:t>
             </a:r>
@@ -4721,34 +4773,41 @@
               <a:rPr lang="en-US" sz="1600" dirty="0">
                 <a:latin typeface="Centaur" panose="02030504050205020304" pitchFamily="18" charset="77"/>
               </a:rPr>
-              <a:t>) invoice</a:t>
+              <a:t>) </a:t>
+            </a:r>
+            <a:r>
+              <a:rPr lang="en-US" sz="1700" dirty="0">
+                <a:latin typeface="Centaur" panose="02030504050205020304" pitchFamily="18" charset="77"/>
+              </a:rPr>
+              <a:t>invoice</a:t>
             </a:r>
           </a:p>
         </p:txBody>
       </p:sp>
       <p:cxnSp>
         <p:nvCxnSpPr>
-          <p:cNvPr id="30" name="Elbow Connector 29">
-            <a:extLst>
-              <a:ext uri="{FF2B5EF4-FFF2-40B4-BE49-F238E27FC236}">
-                <a16:creationId xmlns:a16="http://schemas.microsoft.com/office/drawing/2014/main" id="{DAFF932A-32A5-F14F-B3EF-8709B89349F1}"/>
+          <p:cNvPr id="80" name="Elbow Connector 79">
+            <a:extLst>
+              <a:ext uri="{FF2B5EF4-FFF2-40B4-BE49-F238E27FC236}">
+                <a16:creationId xmlns:a16="http://schemas.microsoft.com/office/drawing/2014/main" id="{C9CEE400-C823-9549-9A6B-635153C82F59}"/>
               </a:ext>
             </a:extLst>
           </p:cNvPr>
           <p:cNvCxnSpPr>
-            <a:stCxn id="17" idx="2"/>
-            <a:endCxn id="6" idx="2"/>
+            <a:cxnSpLocks/>
+            <a:stCxn id="67" idx="2"/>
+            <a:endCxn id="52" idx="2"/>
           </p:cNvCxnSpPr>
           <p:nvPr/>
         </p:nvCxnSpPr>
         <p:spPr>
           <a:xfrm rot="5400000" flipH="1" flipV="1">
-            <a:off x="3814647" y="936033"/>
-            <a:ext cx="1538356" cy="2241329"/>
+            <a:off x="3389574" y="1922313"/>
+            <a:ext cx="1538356" cy="2177084"/>
           </a:xfrm>
           <a:prstGeom prst="bentConnector3">
             <a:avLst>
-              <a:gd name="adj1" fmla="val -14860"/>
+              <a:gd name="adj1" fmla="val -6461"/>
             </a:avLst>
           </a:prstGeom>
           <a:ln w="9525" cap="flat" cmpd="sng" algn="ctr">
@@ -4778,10 +4837,10 @@
       </p:cxnSp>
       <p:sp>
         <p:nvSpPr>
-          <p:cNvPr id="31" name="TextBox 30">
-            <a:extLst>
-              <a:ext uri="{FF2B5EF4-FFF2-40B4-BE49-F238E27FC236}">
-                <a16:creationId xmlns:a16="http://schemas.microsoft.com/office/drawing/2014/main" id="{FB39FCFB-EC01-AC46-9DF3-C28567E92A1D}"/>
+          <p:cNvPr id="81" name="TextBox 80">
+            <a:extLst>
+              <a:ext uri="{FF2B5EF4-FFF2-40B4-BE49-F238E27FC236}">
+                <a16:creationId xmlns:a16="http://schemas.microsoft.com/office/drawing/2014/main" id="{21B55CB6-6D63-6F47-8E62-045D0E0A4A39}"/>
               </a:ext>
             </a:extLst>
           </p:cNvPr>
@@ -4790,8 +4849,8 @@
         </p:nvSpPr>
         <p:spPr>
           <a:xfrm>
-            <a:off x="5270381" y="2613993"/>
-            <a:ext cx="1059329" cy="338554"/>
+            <a:off x="4781206" y="3556396"/>
+            <a:ext cx="1086388" cy="353943"/>
           </a:xfrm>
           <a:prstGeom prst="rect">
             <a:avLst/>
@@ -4812,8 +4871,9 @@
               <a:t>(</a:t>
             </a:r>
             <a:r>
-              <a:rPr lang="en-US" sz="1600" b="1" dirty="0">
-                <a:latin typeface="Centaur" panose="02030504050205020304" pitchFamily="18" charset="77"/>
+              <a:rPr lang="en-US" sz="1600" dirty="0">
+                <a:latin typeface="Times New Roman" panose="02020603050405020304" pitchFamily="18" charset="0"/>
+                <a:cs typeface="Times New Roman" panose="02020603050405020304" pitchFamily="18" charset="0"/>
               </a:rPr>
               <a:t>11</a:t>
             </a:r>
@@ -4821,17 +4881,23 @@
               <a:rPr lang="en-US" sz="1600" dirty="0">
                 <a:latin typeface="Centaur" panose="02030504050205020304" pitchFamily="18" charset="77"/>
               </a:rPr>
-              <a:t>) deliver</a:t>
-            </a:r>
-          </a:p>
-        </p:txBody>
-      </p:sp>
-      <p:sp>
-        <p:nvSpPr>
-          <p:cNvPr id="32" name="Rounded Rectangle 31">
-            <a:extLst>
-              <a:ext uri="{FF2B5EF4-FFF2-40B4-BE49-F238E27FC236}">
-                <a16:creationId xmlns:a16="http://schemas.microsoft.com/office/drawing/2014/main" id="{9D360285-070E-7E4C-8A54-DB00190210DA}"/>
+              <a:t>) </a:t>
+            </a:r>
+            <a:r>
+              <a:rPr lang="en-US" sz="1700" dirty="0">
+                <a:latin typeface="Centaur" panose="02030504050205020304" pitchFamily="18" charset="77"/>
+              </a:rPr>
+              <a:t>deliver</a:t>
+            </a:r>
+          </a:p>
+        </p:txBody>
+      </p:sp>
+      <p:sp>
+        <p:nvSpPr>
+          <p:cNvPr id="82" name="Rounded Rectangle 81">
+            <a:extLst>
+              <a:ext uri="{FF2B5EF4-FFF2-40B4-BE49-F238E27FC236}">
+                <a16:creationId xmlns:a16="http://schemas.microsoft.com/office/drawing/2014/main" id="{D0E2A674-FE18-D349-82E8-7A67FC778BDF}"/>
               </a:ext>
             </a:extLst>
           </p:cNvPr>
@@ -4840,7 +4906,7 @@
         </p:nvSpPr>
         <p:spPr>
           <a:xfrm>
-            <a:off x="7709925" y="2567591"/>
+            <a:off x="7292485" y="3521748"/>
             <a:ext cx="1051036" cy="262758"/>
           </a:xfrm>
           <a:prstGeom prst="roundRect">
@@ -4885,23 +4951,23 @@
       </p:sp>
       <p:cxnSp>
         <p:nvCxnSpPr>
-          <p:cNvPr id="33" name="Elbow Connector 32">
-            <a:extLst>
-              <a:ext uri="{FF2B5EF4-FFF2-40B4-BE49-F238E27FC236}">
-                <a16:creationId xmlns:a16="http://schemas.microsoft.com/office/drawing/2014/main" id="{C583FF61-B982-0047-A800-ECDB93595841}"/>
+          <p:cNvPr id="83" name="Elbow Connector 82">
+            <a:extLst>
+              <a:ext uri="{FF2B5EF4-FFF2-40B4-BE49-F238E27FC236}">
+                <a16:creationId xmlns:a16="http://schemas.microsoft.com/office/drawing/2014/main" id="{1F95F7E8-DECB-BB4B-B11D-19BE653CCCB8}"/>
               </a:ext>
             </a:extLst>
           </p:cNvPr>
           <p:cNvCxnSpPr>
-            <a:stCxn id="4" idx="2"/>
-            <a:endCxn id="32" idx="2"/>
+            <a:stCxn id="50" idx="2"/>
+            <a:endCxn id="82" idx="2"/>
           </p:cNvCxnSpPr>
           <p:nvPr/>
         </p:nvCxnSpPr>
         <p:spPr>
           <a:xfrm rot="16200000" flipH="1">
-            <a:off x="7068285" y="1663190"/>
-            <a:ext cx="1542829" cy="791488"/>
+            <a:off x="6630967" y="2597469"/>
+            <a:ext cx="1542829" cy="831244"/>
           </a:xfrm>
           <a:prstGeom prst="bentConnector3">
             <a:avLst>
@@ -4935,10 +5001,10 @@
       </p:cxnSp>
       <p:sp>
         <p:nvSpPr>
-          <p:cNvPr id="34" name="TextBox 33">
-            <a:extLst>
-              <a:ext uri="{FF2B5EF4-FFF2-40B4-BE49-F238E27FC236}">
-                <a16:creationId xmlns:a16="http://schemas.microsoft.com/office/drawing/2014/main" id="{89FF9398-C9D1-AD4F-A47E-BAF16F745B80}"/>
+          <p:cNvPr id="84" name="TextBox 83">
+            <a:extLst>
+              <a:ext uri="{FF2B5EF4-FFF2-40B4-BE49-F238E27FC236}">
+                <a16:creationId xmlns:a16="http://schemas.microsoft.com/office/drawing/2014/main" id="{A5AB511F-1AB3-2D42-A397-2E728E604C0D}"/>
               </a:ext>
             </a:extLst>
           </p:cNvPr>
@@ -4947,8 +5013,8 @@
         </p:nvSpPr>
         <p:spPr>
           <a:xfrm>
-            <a:off x="6260892" y="2760561"/>
-            <a:ext cx="1841787" cy="338554"/>
+            <a:off x="5853475" y="3714718"/>
+            <a:ext cx="2040484" cy="353943"/>
           </a:xfrm>
           <a:prstGeom prst="rect">
             <a:avLst/>
@@ -4969,8 +5035,9 @@
               <a:t>(</a:t>
             </a:r>
             <a:r>
-              <a:rPr lang="en-US" sz="1600" b="1" dirty="0">
-                <a:latin typeface="Centaur" panose="02030504050205020304" pitchFamily="18" charset="77"/>
+              <a:rPr lang="en-US" sz="1600" dirty="0">
+                <a:latin typeface="Times New Roman" panose="02020603050405020304" pitchFamily="18" charset="0"/>
+                <a:cs typeface="Times New Roman" panose="02020603050405020304" pitchFamily="18" charset="0"/>
               </a:rPr>
               <a:t>14</a:t>
             </a:r>
@@ -4978,35 +5045,41 @@
               <a:rPr lang="en-US" sz="1600" dirty="0">
                 <a:latin typeface="Centaur" panose="02030504050205020304" pitchFamily="18" charset="77"/>
               </a:rPr>
-              <a:t>) arrange shipping</a:t>
+              <a:t>) </a:t>
+            </a:r>
+            <a:r>
+              <a:rPr lang="en-US" sz="1700" dirty="0">
+                <a:latin typeface="Centaur" panose="02030504050205020304" pitchFamily="18" charset="77"/>
+              </a:rPr>
+              <a:t>arrange shipping</a:t>
             </a:r>
           </a:p>
         </p:txBody>
       </p:sp>
       <p:cxnSp>
         <p:nvCxnSpPr>
-          <p:cNvPr id="35" name="Elbow Connector 34">
-            <a:extLst>
-              <a:ext uri="{FF2B5EF4-FFF2-40B4-BE49-F238E27FC236}">
-                <a16:creationId xmlns:a16="http://schemas.microsoft.com/office/drawing/2014/main" id="{E4B44F38-5D22-BD41-9D44-21F1A3B5593C}"/>
+          <p:cNvPr id="85" name="Elbow Connector 84">
+            <a:extLst>
+              <a:ext uri="{FF2B5EF4-FFF2-40B4-BE49-F238E27FC236}">
+                <a16:creationId xmlns:a16="http://schemas.microsoft.com/office/drawing/2014/main" id="{436D2F52-E542-E14D-BAB9-8FC0C5BD90AA}"/>
               </a:ext>
             </a:extLst>
           </p:cNvPr>
           <p:cNvCxnSpPr>
             <a:cxnSpLocks/>
-            <a:stCxn id="32" idx="1"/>
-            <a:endCxn id="6" idx="3"/>
+            <a:stCxn id="82" idx="1"/>
+            <a:endCxn id="52" idx="3"/>
           </p:cNvCxnSpPr>
           <p:nvPr/>
         </p:nvCxnSpPr>
         <p:spPr>
           <a:xfrm rot="10800000">
-            <a:off x="6361391" y="1140376"/>
-            <a:ext cx="1348534" cy="1558595"/>
+            <a:off x="5904195" y="2094533"/>
+            <a:ext cx="1388290" cy="1558595"/>
           </a:xfrm>
           <a:prstGeom prst="bentConnector3">
             <a:avLst>
-              <a:gd name="adj1" fmla="val 109700"/>
+              <a:gd name="adj1" fmla="val 107990"/>
             </a:avLst>
           </a:prstGeom>
           <a:ln w="9525" cap="flat" cmpd="sng" algn="ctr">
@@ -5036,10 +5109,10 @@
       </p:cxnSp>
       <p:sp>
         <p:nvSpPr>
-          <p:cNvPr id="36" name="TextBox 35">
-            <a:extLst>
-              <a:ext uri="{FF2B5EF4-FFF2-40B4-BE49-F238E27FC236}">
-                <a16:creationId xmlns:a16="http://schemas.microsoft.com/office/drawing/2014/main" id="{99AA1699-CBF7-934C-BCBD-F3D83EC3AEB4}"/>
+          <p:cNvPr id="86" name="TextBox 85">
+            <a:extLst>
+              <a:ext uri="{FF2B5EF4-FFF2-40B4-BE49-F238E27FC236}">
+                <a16:creationId xmlns:a16="http://schemas.microsoft.com/office/drawing/2014/main" id="{ED1C6862-6537-5A4C-8A2E-6279EC9EB7A9}"/>
               </a:ext>
             </a:extLst>
           </p:cNvPr>
@@ -5048,8 +5121,8 @@
         </p:nvSpPr>
         <p:spPr>
           <a:xfrm>
-            <a:off x="6198438" y="2433701"/>
-            <a:ext cx="1180644" cy="338554"/>
+            <a:off x="5690341" y="3329980"/>
+            <a:ext cx="1220463" cy="353943"/>
           </a:xfrm>
           <a:prstGeom prst="rect">
             <a:avLst/>
@@ -5070,8 +5143,9 @@
               <a:t>(</a:t>
             </a:r>
             <a:r>
-              <a:rPr lang="en-US" sz="1600" b="1" dirty="0">
-                <a:latin typeface="Centaur" panose="02030504050205020304" pitchFamily="18" charset="77"/>
+              <a:rPr lang="en-US" sz="1600" dirty="0">
+                <a:latin typeface="Times New Roman" panose="02020603050405020304" pitchFamily="18" charset="0"/>
+                <a:cs typeface="Times New Roman" panose="02020603050405020304" pitchFamily="18" charset="0"/>
               </a:rPr>
               <a:t>15</a:t>
             </a:r>
@@ -5079,17 +5153,23 @@
               <a:rPr lang="en-US" sz="1600" dirty="0">
                 <a:latin typeface="Centaur" panose="02030504050205020304" pitchFamily="18" charset="77"/>
               </a:rPr>
-              <a:t>) pick up </a:t>
-            </a:r>
-          </a:p>
-        </p:txBody>
-      </p:sp>
-      <p:sp>
-        <p:nvSpPr>
-          <p:cNvPr id="37" name="TextBox 36">
-            <a:extLst>
-              <a:ext uri="{FF2B5EF4-FFF2-40B4-BE49-F238E27FC236}">
-                <a16:creationId xmlns:a16="http://schemas.microsoft.com/office/drawing/2014/main" id="{512AA128-D39C-0446-B5B9-6F7985A8D002}"/>
+              <a:t>) </a:t>
+            </a:r>
+            <a:r>
+              <a:rPr lang="en-US" sz="1700" dirty="0">
+                <a:latin typeface="Centaur" panose="02030504050205020304" pitchFamily="18" charset="77"/>
+              </a:rPr>
+              <a:t>pick up </a:t>
+            </a:r>
+          </a:p>
+        </p:txBody>
+      </p:sp>
+      <p:sp>
+        <p:nvSpPr>
+          <p:cNvPr id="87" name="TextBox 86">
+            <a:extLst>
+              <a:ext uri="{FF2B5EF4-FFF2-40B4-BE49-F238E27FC236}">
+                <a16:creationId xmlns:a16="http://schemas.microsoft.com/office/drawing/2014/main" id="{EA7CE470-A959-3743-B1F8-E02A09966A5D}"/>
               </a:ext>
             </a:extLst>
           </p:cNvPr>
@@ -5098,8 +5178,8 @@
         </p:nvSpPr>
         <p:spPr>
           <a:xfrm>
-            <a:off x="8676940" y="2006882"/>
-            <a:ext cx="1059329" cy="338554"/>
+            <a:off x="8122771" y="3050186"/>
+            <a:ext cx="1094018" cy="353943"/>
           </a:xfrm>
           <a:prstGeom prst="rect">
             <a:avLst/>
@@ -5120,8 +5200,9 @@
               <a:t>(</a:t>
             </a:r>
             <a:r>
-              <a:rPr lang="en-US" sz="1600" b="1" dirty="0">
-                <a:latin typeface="Centaur" panose="02030504050205020304" pitchFamily="18" charset="77"/>
+              <a:rPr lang="en-US" sz="1600" dirty="0">
+                <a:latin typeface="Times New Roman" panose="02020603050405020304" pitchFamily="18" charset="0"/>
+                <a:cs typeface="Times New Roman" panose="02020603050405020304" pitchFamily="18" charset="0"/>
               </a:rPr>
               <a:t>16</a:t>
             </a:r>
@@ -5129,30 +5210,37 @@
               <a:rPr lang="en-US" sz="1600" dirty="0">
                 <a:latin typeface="Centaur" panose="02030504050205020304" pitchFamily="18" charset="77"/>
               </a:rPr>
-              <a:t>) deliver</a:t>
+              <a:t>) </a:t>
+            </a:r>
+            <a:r>
+              <a:rPr lang="en-US" sz="1700" dirty="0">
+                <a:latin typeface="Centaur" panose="02030504050205020304" pitchFamily="18" charset="77"/>
+              </a:rPr>
+              <a:t>deliver</a:t>
             </a:r>
           </a:p>
         </p:txBody>
       </p:sp>
       <p:cxnSp>
         <p:nvCxnSpPr>
-          <p:cNvPr id="38" name="Elbow Connector 37">
-            <a:extLst>
-              <a:ext uri="{FF2B5EF4-FFF2-40B4-BE49-F238E27FC236}">
-                <a16:creationId xmlns:a16="http://schemas.microsoft.com/office/drawing/2014/main" id="{7B076481-05AF-6344-82FC-6F6605AEAE96}"/>
+          <p:cNvPr id="88" name="Elbow Connector 87">
+            <a:extLst>
+              <a:ext uri="{FF2B5EF4-FFF2-40B4-BE49-F238E27FC236}">
+                <a16:creationId xmlns:a16="http://schemas.microsoft.com/office/drawing/2014/main" id="{786D15DB-F783-994C-B73D-88304B24AC96}"/>
               </a:ext>
             </a:extLst>
           </p:cNvPr>
           <p:cNvCxnSpPr>
-            <a:stCxn id="32" idx="3"/>
-            <a:endCxn id="5" idx="2"/>
+            <a:cxnSpLocks/>
+            <a:stCxn id="82" idx="3"/>
+            <a:endCxn id="51" idx="2"/>
           </p:cNvCxnSpPr>
           <p:nvPr/>
         </p:nvCxnSpPr>
         <p:spPr>
           <a:xfrm flipV="1">
-            <a:off x="8760961" y="1290146"/>
-            <a:ext cx="325233" cy="1408824"/>
+            <a:off x="8343521" y="2244303"/>
+            <a:ext cx="130043" cy="1408824"/>
           </a:xfrm>
           <a:prstGeom prst="bentConnector2">
             <a:avLst/>
@@ -5184,28 +5272,28 @@
       </p:cxnSp>
       <p:cxnSp>
         <p:nvCxnSpPr>
-          <p:cNvPr id="49" name="Curved Connector 48">
-            <a:extLst>
-              <a:ext uri="{FF2B5EF4-FFF2-40B4-BE49-F238E27FC236}">
-                <a16:creationId xmlns:a16="http://schemas.microsoft.com/office/drawing/2014/main" id="{00B113C9-BE29-724C-A67E-F6A6CFCBAE54}"/>
+          <p:cNvPr id="89" name="Curved Connector 88">
+            <a:extLst>
+              <a:ext uri="{FF2B5EF4-FFF2-40B4-BE49-F238E27FC236}">
+                <a16:creationId xmlns:a16="http://schemas.microsoft.com/office/drawing/2014/main" id="{2E2332CD-C9B4-DD47-8D1B-CDB9740427E6}"/>
               </a:ext>
             </a:extLst>
           </p:cNvPr>
           <p:cNvCxnSpPr>
-            <a:stCxn id="7" idx="2"/>
-            <a:endCxn id="8" idx="3"/>
+            <a:stCxn id="53" idx="2"/>
+            <a:endCxn id="55" idx="3"/>
           </p:cNvCxnSpPr>
           <p:nvPr/>
         </p:nvCxnSpPr>
         <p:spPr>
           <a:xfrm rot="5400000" flipH="1">
-            <a:off x="3561710" y="721287"/>
-            <a:ext cx="149770" cy="987947"/>
+            <a:off x="3233721" y="1794712"/>
+            <a:ext cx="149770" cy="749411"/>
           </a:xfrm>
           <a:prstGeom prst="curvedConnector4">
             <a:avLst>
-              <a:gd name="adj1" fmla="val -232270"/>
-              <a:gd name="adj2" fmla="val 72607"/>
+              <a:gd name="adj1" fmla="val -152634"/>
+              <a:gd name="adj2" fmla="val 79803"/>
             </a:avLst>
           </a:prstGeom>
           <a:ln w="9525" cap="flat" cmpd="sng" algn="ctr">
@@ -5235,28 +5323,28 @@
       </p:cxnSp>
       <p:cxnSp>
         <p:nvCxnSpPr>
-          <p:cNvPr id="54" name="Curved Connector 53">
-            <a:extLst>
-              <a:ext uri="{FF2B5EF4-FFF2-40B4-BE49-F238E27FC236}">
-                <a16:creationId xmlns:a16="http://schemas.microsoft.com/office/drawing/2014/main" id="{9C0222E1-AD96-8843-BEE8-8FE90793F6E2}"/>
+          <p:cNvPr id="90" name="Curved Connector 89">
+            <a:extLst>
+              <a:ext uri="{FF2B5EF4-FFF2-40B4-BE49-F238E27FC236}">
+                <a16:creationId xmlns:a16="http://schemas.microsoft.com/office/drawing/2014/main" id="{89DCD01B-0B72-C641-BE66-0A8F94AD4C1E}"/>
               </a:ext>
             </a:extLst>
           </p:cNvPr>
           <p:cNvCxnSpPr>
-            <a:stCxn id="6" idx="2"/>
-            <a:endCxn id="7" idx="3"/>
+            <a:stCxn id="52" idx="2"/>
+            <a:endCxn id="53" idx="3"/>
           </p:cNvCxnSpPr>
           <p:nvPr/>
         </p:nvCxnSpPr>
         <p:spPr>
           <a:xfrm rot="5400000" flipH="1">
-            <a:off x="5067961" y="650992"/>
-            <a:ext cx="145833" cy="1127224"/>
+            <a:off x="4615735" y="1610119"/>
+            <a:ext cx="145833" cy="1117285"/>
           </a:xfrm>
           <a:prstGeom prst="curvedConnector4">
             <a:avLst>
-              <a:gd name="adj1" fmla="val -258988"/>
-              <a:gd name="adj2" fmla="val 79138"/>
+              <a:gd name="adj1" fmla="val -156755"/>
+              <a:gd name="adj2" fmla="val 79397"/>
             </a:avLst>
           </a:prstGeom>
           <a:ln w="9525" cap="flat" cmpd="sng" algn="ctr">
@@ -5286,27 +5374,27 @@
       </p:cxnSp>
       <p:cxnSp>
         <p:nvCxnSpPr>
-          <p:cNvPr id="57" name="Curved Connector 56">
-            <a:extLst>
-              <a:ext uri="{FF2B5EF4-FFF2-40B4-BE49-F238E27FC236}">
-                <a16:creationId xmlns:a16="http://schemas.microsoft.com/office/drawing/2014/main" id="{0A866E6C-E652-4E41-A531-48A4786E81BF}"/>
+          <p:cNvPr id="91" name="Curved Connector 90">
+            <a:extLst>
+              <a:ext uri="{FF2B5EF4-FFF2-40B4-BE49-F238E27FC236}">
+                <a16:creationId xmlns:a16="http://schemas.microsoft.com/office/drawing/2014/main" id="{2D123B43-5E49-E046-A73A-DEF07A0C29E7}"/>
               </a:ext>
             </a:extLst>
           </p:cNvPr>
           <p:cNvCxnSpPr>
-            <a:stCxn id="4" idx="2"/>
-            <a:endCxn id="6" idx="3"/>
+            <a:stCxn id="50" idx="2"/>
+            <a:endCxn id="52" idx="3"/>
           </p:cNvCxnSpPr>
           <p:nvPr/>
         </p:nvCxnSpPr>
         <p:spPr>
           <a:xfrm rot="5400000" flipH="1">
-            <a:off x="6829100" y="672666"/>
+            <a:off x="6371904" y="1626823"/>
             <a:ext cx="147145" cy="1082564"/>
           </a:xfrm>
           <a:prstGeom prst="curvedConnector4">
             <a:avLst>
-              <a:gd name="adj1" fmla="val -243168"/>
+              <a:gd name="adj1" fmla="val -155357"/>
               <a:gd name="adj2" fmla="val 76335"/>
             </a:avLst>
           </a:prstGeom>
@@ -5337,10 +5425,10 @@
       </p:cxnSp>
       <p:sp>
         <p:nvSpPr>
-          <p:cNvPr id="2" name="TextBox 1">
-            <a:extLst>
-              <a:ext uri="{FF2B5EF4-FFF2-40B4-BE49-F238E27FC236}">
-                <a16:creationId xmlns:a16="http://schemas.microsoft.com/office/drawing/2014/main" id="{E7584665-54B9-E04E-8037-30C91065BCF2}"/>
+          <p:cNvPr id="92" name="TextBox 91">
+            <a:extLst>
+              <a:ext uri="{FF2B5EF4-FFF2-40B4-BE49-F238E27FC236}">
+                <a16:creationId xmlns:a16="http://schemas.microsoft.com/office/drawing/2014/main" id="{0349F927-5A95-294D-940C-7392538B2BF0}"/>
               </a:ext>
             </a:extLst>
           </p:cNvPr>
@@ -5349,8 +5437,8 @@
         </p:nvSpPr>
         <p:spPr>
           <a:xfrm>
-            <a:off x="4514925" y="1518437"/>
-            <a:ext cx="1287212" cy="584775"/>
+            <a:off x="4329957" y="2372987"/>
+            <a:ext cx="1336071" cy="615553"/>
           </a:xfrm>
           <a:prstGeom prst="rect">
             <a:avLst/>
@@ -5370,8 +5458,9 @@
               <a:t>(</a:t>
             </a:r>
             <a:r>
-              <a:rPr lang="en-US" sz="1600" b="1" dirty="0">
-                <a:latin typeface="Centaur" panose="02030504050205020304" pitchFamily="18" charset="77"/>
+              <a:rPr lang="en-US" sz="1600" dirty="0">
+                <a:latin typeface="Times New Roman" panose="02020603050405020304" pitchFamily="18" charset="0"/>
+                <a:cs typeface="Times New Roman" panose="02020603050405020304" pitchFamily="18" charset="0"/>
               </a:rPr>
               <a:t>12</a:t>
             </a:r>
@@ -5379,15 +5468,21 @@
               <a:rPr lang="en-US" sz="1600" dirty="0">
                 <a:latin typeface="Centaur" panose="02030504050205020304" pitchFamily="18" charset="77"/>
               </a:rPr>
-              <a:t>) proof of </a:t>
+              <a:t>) </a:t>
+            </a:r>
+            <a:r>
+              <a:rPr lang="en-US" sz="1700" dirty="0">
+                <a:latin typeface="Centaur" panose="02030504050205020304" pitchFamily="18" charset="77"/>
+              </a:rPr>
+              <a:t>proof of </a:t>
             </a:r>
             <a:br>
-              <a:rPr lang="en-US" sz="1600" dirty="0">
+              <a:rPr lang="en-US" sz="1700" dirty="0">
                 <a:latin typeface="Centaur" panose="02030504050205020304" pitchFamily="18" charset="77"/>
               </a:rPr>
             </a:br>
             <a:r>
-              <a:rPr lang="en-US" sz="1600" dirty="0">
+              <a:rPr lang="en-US" sz="1700" dirty="0">
                 <a:latin typeface="Centaur" panose="02030504050205020304" pitchFamily="18" charset="77"/>
               </a:rPr>
               <a:t>payment</a:t>
@@ -5397,10 +5492,10 @@
       </p:sp>
       <p:sp>
         <p:nvSpPr>
-          <p:cNvPr id="41" name="TextBox 40">
-            <a:extLst>
-              <a:ext uri="{FF2B5EF4-FFF2-40B4-BE49-F238E27FC236}">
-                <a16:creationId xmlns:a16="http://schemas.microsoft.com/office/drawing/2014/main" id="{C856B337-9390-5C45-A17B-366AEA04B19C}"/>
+          <p:cNvPr id="93" name="TextBox 92">
+            <a:extLst>
+              <a:ext uri="{FF2B5EF4-FFF2-40B4-BE49-F238E27FC236}">
+                <a16:creationId xmlns:a16="http://schemas.microsoft.com/office/drawing/2014/main" id="{8B8F5AE3-6A90-AB48-A1AC-FC960A4AA607}"/>
               </a:ext>
             </a:extLst>
           </p:cNvPr>
@@ -5409,8 +5504,8 @@
         </p:nvSpPr>
         <p:spPr>
           <a:xfrm>
-            <a:off x="2897681" y="1513776"/>
-            <a:ext cx="1287212" cy="584775"/>
+            <a:off x="2728085" y="2370530"/>
+            <a:ext cx="1336071" cy="615553"/>
           </a:xfrm>
           <a:prstGeom prst="rect">
             <a:avLst/>
@@ -5430,8 +5525,9 @@
               <a:t>(</a:t>
             </a:r>
             <a:r>
-              <a:rPr lang="en-US" sz="1600" b="1" dirty="0">
-                <a:latin typeface="Centaur" panose="02030504050205020304" pitchFamily="18" charset="77"/>
+              <a:rPr lang="en-US" sz="1600" dirty="0">
+                <a:latin typeface="Times New Roman" panose="02020603050405020304" pitchFamily="18" charset="0"/>
+                <a:cs typeface="Times New Roman" panose="02020603050405020304" pitchFamily="18" charset="0"/>
               </a:rPr>
               <a:t>13</a:t>
             </a:r>
@@ -5439,15 +5535,21 @@
               <a:rPr lang="en-US" sz="1600" dirty="0">
                 <a:latin typeface="Centaur" panose="02030504050205020304" pitchFamily="18" charset="77"/>
               </a:rPr>
-              <a:t>) proof of </a:t>
+              <a:t>) </a:t>
+            </a:r>
+            <a:r>
+              <a:rPr lang="en-US" sz="1700" dirty="0">
+                <a:latin typeface="Centaur" panose="02030504050205020304" pitchFamily="18" charset="77"/>
+              </a:rPr>
+              <a:t>proof of </a:t>
             </a:r>
             <a:br>
-              <a:rPr lang="en-US" sz="1600" dirty="0">
+              <a:rPr lang="en-US" sz="1700" dirty="0">
                 <a:latin typeface="Centaur" panose="02030504050205020304" pitchFamily="18" charset="77"/>
               </a:rPr>
             </a:br>
             <a:r>
-              <a:rPr lang="en-US" sz="1600" dirty="0">
+              <a:rPr lang="en-US" sz="1700" dirty="0">
                 <a:latin typeface="Centaur" panose="02030504050205020304" pitchFamily="18" charset="77"/>
               </a:rPr>
               <a:t>payment</a:t>
@@ -5457,28 +5559,29 @@
       </p:sp>
       <p:cxnSp>
         <p:nvCxnSpPr>
-          <p:cNvPr id="40" name="Curved Connector 39">
-            <a:extLst>
-              <a:ext uri="{FF2B5EF4-FFF2-40B4-BE49-F238E27FC236}">
-                <a16:creationId xmlns:a16="http://schemas.microsoft.com/office/drawing/2014/main" id="{573D92B8-3BD7-FD4E-8AD5-8ABF13D146E7}"/>
+          <p:cNvPr id="94" name="Curved Connector 93">
+            <a:extLst>
+              <a:ext uri="{FF2B5EF4-FFF2-40B4-BE49-F238E27FC236}">
+                <a16:creationId xmlns:a16="http://schemas.microsoft.com/office/drawing/2014/main" id="{21674FA9-5BDD-584E-A731-F303A0D9AC84}"/>
               </a:ext>
             </a:extLst>
           </p:cNvPr>
           <p:cNvCxnSpPr>
-            <a:stCxn id="5" idx="2"/>
-            <a:endCxn id="4" idx="3"/>
+            <a:cxnSpLocks/>
+            <a:stCxn id="51" idx="2"/>
+            <a:endCxn id="50" idx="3"/>
           </p:cNvCxnSpPr>
           <p:nvPr/>
         </p:nvCxnSpPr>
         <p:spPr>
           <a:xfrm rot="5400000" flipH="1">
-            <a:off x="8475283" y="679236"/>
-            <a:ext cx="149771" cy="1072050"/>
+            <a:off x="7940370" y="1711110"/>
+            <a:ext cx="149771" cy="916616"/>
           </a:xfrm>
           <a:prstGeom prst="curvedConnector4">
             <a:avLst>
-              <a:gd name="adj1" fmla="val -225632"/>
-              <a:gd name="adj2" fmla="val 80638"/>
+              <a:gd name="adj1" fmla="val -152633"/>
+              <a:gd name="adj2" fmla="val 77896"/>
             </a:avLst>
           </a:prstGeom>
           <a:ln w="9525" cap="flat" cmpd="sng" algn="ctr">
@@ -5508,10 +5611,10 @@
       </p:cxnSp>
       <p:sp>
         <p:nvSpPr>
-          <p:cNvPr id="46" name="TextBox 45">
-            <a:extLst>
-              <a:ext uri="{FF2B5EF4-FFF2-40B4-BE49-F238E27FC236}">
-                <a16:creationId xmlns:a16="http://schemas.microsoft.com/office/drawing/2014/main" id="{E1A9D5CD-061C-844B-BC1D-C01513865715}"/>
+          <p:cNvPr id="95" name="TextBox 94">
+            <a:extLst>
+              <a:ext uri="{FF2B5EF4-FFF2-40B4-BE49-F238E27FC236}">
+                <a16:creationId xmlns:a16="http://schemas.microsoft.com/office/drawing/2014/main" id="{176F4B14-9071-DF45-8972-09ADBF242D43}"/>
               </a:ext>
             </a:extLst>
           </p:cNvPr>
@@ -5520,8 +5623,8 @@
         </p:nvSpPr>
         <p:spPr>
           <a:xfrm>
-            <a:off x="7858066" y="1504146"/>
-            <a:ext cx="1287212" cy="584775"/>
+            <a:off x="7694492" y="2377572"/>
+            <a:ext cx="1336071" cy="615553"/>
           </a:xfrm>
           <a:prstGeom prst="rect">
             <a:avLst/>
@@ -5541,8 +5644,9 @@
               <a:t>(</a:t>
             </a:r>
             <a:r>
-              <a:rPr lang="en-US" sz="1600" b="1" dirty="0">
-                <a:latin typeface="Centaur" panose="02030504050205020304" pitchFamily="18" charset="77"/>
+              <a:rPr lang="en-US" sz="1600" dirty="0">
+                <a:latin typeface="Times New Roman" panose="02020603050405020304" pitchFamily="18" charset="0"/>
+                <a:cs typeface="Times New Roman" panose="02020603050405020304" pitchFamily="18" charset="0"/>
               </a:rPr>
               <a:t>17</a:t>
             </a:r>
@@ -5550,15 +5654,21 @@
               <a:rPr lang="en-US" sz="1600" dirty="0">
                 <a:latin typeface="Centaur" panose="02030504050205020304" pitchFamily="18" charset="77"/>
               </a:rPr>
-              <a:t>) proof of </a:t>
+              <a:t>) </a:t>
+            </a:r>
+            <a:r>
+              <a:rPr lang="en-US" sz="1700" dirty="0">
+                <a:latin typeface="Centaur" panose="02030504050205020304" pitchFamily="18" charset="77"/>
+              </a:rPr>
+              <a:t>proof of </a:t>
             </a:r>
             <a:br>
-              <a:rPr lang="en-US" sz="1600" dirty="0">
+              <a:rPr lang="en-US" sz="1700" dirty="0">
                 <a:latin typeface="Centaur" panose="02030504050205020304" pitchFamily="18" charset="77"/>
               </a:rPr>
             </a:br>
             <a:r>
-              <a:rPr lang="en-US" sz="1600" dirty="0">
+              <a:rPr lang="en-US" sz="1700" dirty="0">
                 <a:latin typeface="Centaur" panose="02030504050205020304" pitchFamily="18" charset="77"/>
               </a:rPr>
               <a:t>payment</a:t>
@@ -5568,10 +5678,10 @@
       </p:sp>
       <p:sp>
         <p:nvSpPr>
-          <p:cNvPr id="47" name="TextBox 46">
-            <a:extLst>
-              <a:ext uri="{FF2B5EF4-FFF2-40B4-BE49-F238E27FC236}">
-                <a16:creationId xmlns:a16="http://schemas.microsoft.com/office/drawing/2014/main" id="{54B3091B-7B29-9949-AACE-FB032DF13F13}"/>
+          <p:cNvPr id="96" name="TextBox 95">
+            <a:extLst>
+              <a:ext uri="{FF2B5EF4-FFF2-40B4-BE49-F238E27FC236}">
+                <a16:creationId xmlns:a16="http://schemas.microsoft.com/office/drawing/2014/main" id="{7A725362-4896-4846-893E-E7E627E43217}"/>
               </a:ext>
             </a:extLst>
           </p:cNvPr>
@@ -5580,8 +5690,8 @@
         </p:nvSpPr>
         <p:spPr>
           <a:xfrm>
-            <a:off x="6246721" y="1519362"/>
-            <a:ext cx="1287212" cy="584775"/>
+            <a:off x="6060969" y="2383162"/>
+            <a:ext cx="1336071" cy="615553"/>
           </a:xfrm>
           <a:prstGeom prst="rect">
             <a:avLst/>
@@ -5601,8 +5711,9 @@
               <a:t>(</a:t>
             </a:r>
             <a:r>
-              <a:rPr lang="en-US" sz="1600" b="1" dirty="0">
-                <a:latin typeface="Centaur" panose="02030504050205020304" pitchFamily="18" charset="77"/>
+              <a:rPr lang="en-US" sz="1600" dirty="0">
+                <a:latin typeface="Times New Roman" panose="02020603050405020304" pitchFamily="18" charset="0"/>
+                <a:cs typeface="Times New Roman" panose="02020603050405020304" pitchFamily="18" charset="0"/>
               </a:rPr>
               <a:t>18</a:t>
             </a:r>
@@ -5610,15 +5721,21 @@
               <a:rPr lang="en-US" sz="1600" dirty="0">
                 <a:latin typeface="Centaur" panose="02030504050205020304" pitchFamily="18" charset="77"/>
               </a:rPr>
-              <a:t>) proof of </a:t>
+              <a:t>) </a:t>
+            </a:r>
+            <a:r>
+              <a:rPr lang="en-US" sz="1700" dirty="0">
+                <a:latin typeface="Centaur" panose="02030504050205020304" pitchFamily="18" charset="77"/>
+              </a:rPr>
+              <a:t>proof of </a:t>
             </a:r>
             <a:br>
-              <a:rPr lang="en-US" sz="1600" dirty="0">
+              <a:rPr lang="en-US" sz="1700" dirty="0">
                 <a:latin typeface="Centaur" panose="02030504050205020304" pitchFamily="18" charset="77"/>
               </a:rPr>
             </a:br>
             <a:r>
-              <a:rPr lang="en-US" sz="1600" dirty="0">
+              <a:rPr lang="en-US" sz="1700" dirty="0">
                 <a:latin typeface="Centaur" panose="02030504050205020304" pitchFamily="18" charset="77"/>
               </a:rPr>
               <a:t>payment</a:t>
@@ -5628,28 +5745,29 @@
       </p:sp>
       <p:cxnSp>
         <p:nvCxnSpPr>
-          <p:cNvPr id="56" name="Curved Connector 55">
-            <a:extLst>
-              <a:ext uri="{FF2B5EF4-FFF2-40B4-BE49-F238E27FC236}">
-                <a16:creationId xmlns:a16="http://schemas.microsoft.com/office/drawing/2014/main" id="{BF4BF2F7-951B-B941-A500-BF66EBC73519}"/>
+          <p:cNvPr id="97" name="Curved Connector 96">
+            <a:extLst>
+              <a:ext uri="{FF2B5EF4-FFF2-40B4-BE49-F238E27FC236}">
+                <a16:creationId xmlns:a16="http://schemas.microsoft.com/office/drawing/2014/main" id="{7953ABF6-FE92-A74D-A65F-5533008C8AD3}"/>
               </a:ext>
             </a:extLst>
           </p:cNvPr>
           <p:cNvCxnSpPr>
-            <a:stCxn id="5" idx="0"/>
-            <a:endCxn id="5" idx="3"/>
+            <a:cxnSpLocks/>
+            <a:stCxn id="51" idx="0"/>
+            <a:endCxn id="51" idx="3"/>
           </p:cNvCxnSpPr>
           <p:nvPr/>
         </p:nvCxnSpPr>
         <p:spPr>
           <a:xfrm rot="16200000" flipH="1">
-            <a:off x="9341071" y="740978"/>
-            <a:ext cx="147145" cy="656901"/>
+            <a:off x="8655693" y="1767883"/>
+            <a:ext cx="147145" cy="511405"/>
           </a:xfrm>
           <a:prstGeom prst="curvedConnector4">
             <a:avLst>
               <a:gd name="adj1" fmla="val -155357"/>
-              <a:gd name="adj2" fmla="val 134800"/>
+              <a:gd name="adj2" fmla="val 144700"/>
             </a:avLst>
           </a:prstGeom>
           <a:ln w="9525" cap="flat" cmpd="sng" algn="ctr">
@@ -5679,10 +5797,10 @@
       </p:cxnSp>
       <p:sp>
         <p:nvSpPr>
-          <p:cNvPr id="58" name="TextBox 57">
-            <a:extLst>
-              <a:ext uri="{FF2B5EF4-FFF2-40B4-BE49-F238E27FC236}">
-                <a16:creationId xmlns:a16="http://schemas.microsoft.com/office/drawing/2014/main" id="{8D4BC898-9F9B-3449-AC7F-82EC5701D98E}"/>
+          <p:cNvPr id="98" name="TextBox 97">
+            <a:extLst>
+              <a:ext uri="{FF2B5EF4-FFF2-40B4-BE49-F238E27FC236}">
+                <a16:creationId xmlns:a16="http://schemas.microsoft.com/office/drawing/2014/main" id="{4ADC3464-F105-6C41-B21B-F4F47CC898C7}"/>
               </a:ext>
             </a:extLst>
           </p:cNvPr>
@@ -5691,8 +5809,8 @@
         </p:nvSpPr>
         <p:spPr>
           <a:xfrm>
-            <a:off x="8682857" y="394096"/>
-            <a:ext cx="1501758" cy="584775"/>
+            <a:off x="7765307" y="1327540"/>
+            <a:ext cx="1586203" cy="615553"/>
           </a:xfrm>
           <a:prstGeom prst="rect">
             <a:avLst/>
@@ -5712,8 +5830,9 @@
               <a:t>(</a:t>
             </a:r>
             <a:r>
-              <a:rPr lang="en-US" sz="1600" b="1" dirty="0">
-                <a:latin typeface="Centaur" panose="02030504050205020304" pitchFamily="18" charset="77"/>
+              <a:rPr lang="en-US" sz="1600" dirty="0">
+                <a:latin typeface="Times New Roman" panose="02020603050405020304" pitchFamily="18" charset="0"/>
+                <a:cs typeface="Times New Roman" panose="02020603050405020304" pitchFamily="18" charset="0"/>
               </a:rPr>
               <a:t>18</a:t>
             </a:r>
@@ -5721,18 +5840,114 @@
               <a:rPr lang="en-US" sz="1600" dirty="0">
                 <a:latin typeface="Centaur" panose="02030504050205020304" pitchFamily="18" charset="77"/>
               </a:rPr>
-              <a:t>) sales record </a:t>
+              <a:t>) </a:t>
+            </a:r>
+            <a:r>
+              <a:rPr lang="en-US" sz="1700" dirty="0">
+                <a:latin typeface="Centaur" panose="02030504050205020304" pitchFamily="18" charset="77"/>
+              </a:rPr>
+              <a:t>sales record </a:t>
             </a:r>
             <a:br>
-              <a:rPr lang="en-US" sz="1600" dirty="0">
+              <a:rPr lang="en-US" sz="1700" dirty="0">
                 <a:latin typeface="Centaur" panose="02030504050205020304" pitchFamily="18" charset="77"/>
               </a:rPr>
             </a:br>
             <a:r>
-              <a:rPr lang="en-US" sz="1600" dirty="0">
+              <a:rPr lang="en-US" sz="1700" dirty="0">
                 <a:latin typeface="Centaur" panose="02030504050205020304" pitchFamily="18" charset="77"/>
               </a:rPr>
               <a:t>for each customer</a:t>
+            </a:r>
+          </a:p>
+        </p:txBody>
+      </p:sp>
+      <p:sp>
+        <p:nvSpPr>
+          <p:cNvPr id="99" name="Rectangle 98">
+            <a:extLst>
+              <a:ext uri="{FF2B5EF4-FFF2-40B4-BE49-F238E27FC236}">
+                <a16:creationId xmlns:a16="http://schemas.microsoft.com/office/drawing/2014/main" id="{7502AB86-688A-DC47-BA47-DC9D26655542}"/>
+              </a:ext>
+            </a:extLst>
+          </p:cNvPr>
+          <p:cNvSpPr/>
+          <p:nvPr/>
+        </p:nvSpPr>
+        <p:spPr>
+          <a:xfrm>
+            <a:off x="2040504" y="4083089"/>
+            <a:ext cx="6944464" cy="232788"/>
+          </a:xfrm>
+          <a:prstGeom prst="rect">
+            <a:avLst/>
+          </a:prstGeom>
+        </p:spPr>
+        <p:style>
+          <a:lnRef idx="2">
+            <a:schemeClr val="accent1">
+              <a:shade val="50000"/>
+            </a:schemeClr>
+          </a:lnRef>
+          <a:fillRef idx="1">
+            <a:schemeClr val="accent1"/>
+          </a:fillRef>
+          <a:effectRef idx="0">
+            <a:schemeClr val="accent1"/>
+          </a:effectRef>
+          <a:fontRef idx="minor">
+            <a:schemeClr val="lt1"/>
+          </a:fontRef>
+        </p:style>
+        <p:txBody>
+          <a:bodyPr rtlCol="0" anchor="ctr"/>
+          <a:lstStyle/>
+          <a:p>
+            <a:pPr algn="ctr"/>
+            <a:r>
+              <a:rPr lang="en-US" sz="1700" b="1" dirty="0">
+                <a:latin typeface="Centaur" panose="02030504050205020304" pitchFamily="18" charset="77"/>
+                <a:cs typeface="Times New Roman" panose="02020603050405020304" pitchFamily="18" charset="0"/>
+              </a:rPr>
+              <a:t>Order details, invoice, proof of payment, logistics details</a:t>
+            </a:r>
+          </a:p>
+        </p:txBody>
+      </p:sp>
+      <p:sp>
+        <p:nvSpPr>
+          <p:cNvPr id="100" name="TextBox 99">
+            <a:extLst>
+              <a:ext uri="{FF2B5EF4-FFF2-40B4-BE49-F238E27FC236}">
+                <a16:creationId xmlns:a16="http://schemas.microsoft.com/office/drawing/2014/main" id="{A8BAE074-A2CD-664E-9792-50AEA2575D83}"/>
+              </a:ext>
+            </a:extLst>
+          </p:cNvPr>
+          <p:cNvSpPr txBox="1"/>
+          <p:nvPr/>
+        </p:nvSpPr>
+        <p:spPr>
+          <a:xfrm>
+            <a:off x="4827861" y="4264990"/>
+            <a:ext cx="1623778" cy="353943"/>
+          </a:xfrm>
+          <a:prstGeom prst="rect">
+            <a:avLst/>
+          </a:prstGeom>
+          <a:noFill/>
+        </p:spPr>
+        <p:txBody>
+          <a:bodyPr wrap="none" rtlCol="0">
+            <a:spAutoFit/>
+          </a:bodyPr>
+          <a:lstStyle/>
+          <a:p>
+            <a:r>
+              <a:rPr lang="en-US" sz="1700" b="1" dirty="0">
+                <a:latin typeface="Centaur" panose="02030504050205020304" pitchFamily="18" charset="77"/>
+                <a:cs typeface="Times New Roman" panose="02020603050405020304" pitchFamily="18" charset="0"/>
+              </a:rPr>
+              <a:t>Replicated Ledger</a:t>
             </a:r>
           </a:p>
         </p:txBody>

</xml_diff>